<commit_message>
Update message flow PPTX: colour legend on slide 1, business flow on slide 2
Slide 1 (technical swimlane): adds a colour-coded legend bar at the bottom
explaining each colour (simulation layer, EU Data Hub, alarm detection,
AI agent, Ireland investigation, database storage, cross-lane handoff).

Slide 2 (new): business & functional process flow — message journey from
arrival at the EU Custom Data Hub to the Ireland Revenue investigation queue,
presented without implementation detail. 6 process boxes, 3 decision
diamonds (amber), 3 terminal "no-action" branches, colour legend, and
actor tags on each step.

Co-Authored-By: Claude Sonnet 4.6 <noreply@anthropic.com>
</commit_message>
<xml_diff>
--- a/EU_Custom_DataHub_MessageFlow.pptx
+++ b/EU_Custom_DataHub_MessageFlow.pptx
@@ -6,6 +6,7 @@
   </p:sldMasterIdLst>
   <p:sldIdLst>
     <p:sldId id="256" r:id="rId7"/>
+    <p:sldId id="257" r:id="rId8"/>
   </p:sldIdLst>
   <p:sldSz cx="12188952" cy="6858000" type="screen4x3"/>
   <p:notesSz cx="6858000" cy="9144000"/>
@@ -3144,7 +3145,7 @@
                   <a:srgbClr val="FFFFFF"/>
                 </a:solidFill>
               </a:rPr>
-              <a:t>EU Custom Data Hub — Message Flow: from Transaction Generation to Ireland Investigation Queue</a:t>
+              <a:t>EU Custom Data Hub — Technical Message Flow (Swimlane)</a:t>
             </a:r>
           </a:p>
         </p:txBody>
@@ -5134,7 +5135,7 @@
           <a:p>
             <a:pPr algn="ctr"/>
             <a:r>
-              <a:rPr sz="700" b="1">
+              <a:rPr sz="750" b="1">
                 <a:solidFill>
                   <a:srgbClr val="FFFFFF"/>
                 </a:solidFill>
@@ -5493,18 +5494,7 @@
                   <a:srgbClr val="222222"/>
                 </a:solidFill>
               </a:rPr>
-              <a:t>in /api/simulation/</a:t>
-            </a:r>
-          </a:p>
-          <a:p>
-            <a:pPr algn="l"/>
-            <a:r>
-              <a:rPr sz="750" b="0" i="0">
-                <a:solidFill>
-                  <a:srgbClr val="222222"/>
-                </a:solidFill>
-              </a:rPr>
-              <a:t>status.</a:t>
+              <a:t>in simulation/status.</a:t>
             </a:r>
           </a:p>
         </p:txBody>
@@ -5928,7 +5918,7 @@
           <a:p>
             <a:pPr algn="ctr"/>
             <a:r>
-              <a:rPr sz="700" b="1">
+              <a:rPr sz="750" b="1">
                 <a:solidFill>
                   <a:srgbClr val="FFFFFF"/>
                 </a:solidFill>
@@ -6335,7 +6325,7 @@
           <a:p>
             <a:pPr algn="ctr"/>
             <a:r>
-              <a:rPr sz="700" b="1">
+              <a:rPr sz="750" b="1">
                 <a:solidFill>
                   <a:srgbClr val="FFFFFF"/>
                 </a:solidFill>
@@ -6388,7 +6378,7 @@
           <a:p>
             <a:pPr algn="ctr"/>
             <a:r>
-              <a:rPr sz="700" b="1">
+              <a:rPr sz="750" b="1">
                 <a:solidFill>
                   <a:srgbClr val="FFFFFF"/>
                 </a:solidFill>
@@ -6615,7 +6605,7 @@
                   <a:srgbClr val="222222"/>
                 </a:solidFill>
               </a:rPr>
-              <a:t>cases available for</a:t>
+              <a:t>cases for local</a:t>
             </a:r>
           </a:p>
           <a:p>
@@ -6626,7 +6616,7 @@
                   <a:srgbClr val="222222"/>
                 </a:solidFill>
               </a:rPr>
-              <a:t>local investigation.</a:t>
+              <a:t>investigation.</a:t>
             </a:r>
           </a:p>
           <a:p>
@@ -6736,18 +6726,7 @@
                   <a:srgbClr val="222222"/>
                 </a:solidFill>
               </a:rPr>
-              <a:t>Front-end:</a:t>
-            </a:r>
-          </a:p>
-          <a:p>
-            <a:pPr algn="l"/>
-            <a:r>
-              <a:rPr sz="750" b="0" i="0">
-                <a:solidFill>
-                  <a:srgbClr val="222222"/>
-                </a:solidFill>
-              </a:rPr>
-              <a:t>/ireland page</a:t>
+              <a:t>Front-end: /ireland</a:t>
             </a:r>
           </a:p>
         </p:txBody>
@@ -7219,58 +7198,24 @@
       </p:sp>
       <p:sp>
         <p:nvSpPr>
-          <p:cNvPr id="69" name="TextBox 68"/>
-          <p:cNvSpPr txBox="1"/>
-          <p:nvPr/>
-        </p:nvSpPr>
-        <p:spPr>
-          <a:xfrm>
-            <a:off x="164592" y="6620256"/>
-            <a:ext cx="11887200" cy="219456"/>
-          </a:xfrm>
-          <a:prstGeom prst="rect">
-            <a:avLst/>
-          </a:prstGeom>
-          <a:noFill/>
-        </p:spPr>
-        <p:txBody>
-          <a:bodyPr wrap="square">
-            <a:spAutoFit/>
-          </a:bodyPr>
-          <a:lstStyle/>
-          <a:p>
-            <a:pPr algn="l"/>
-            <a:r>
-              <a:rPr sz="650" b="0" i="0">
-                <a:solidFill>
-                  <a:srgbClr val="AAAAAA"/>
-                </a:solidFill>
-              </a:rPr>
-              <a:t>─── EU Data Hub flow (blue)     ─── Ireland investigation flow (green)     ─── Agent handoff: suspicious IE transaction (purple)     All transactions recorded in european_custom.db regardless of flow</a:t>
-            </a:r>
-          </a:p>
-        </p:txBody>
-      </p:sp>
-      <p:sp>
-        <p:nvSpPr>
-          <p:cNvPr id="70" name="Rectangle 69"/>
+          <p:cNvPr id="69" name="Rectangle 68"/>
           <p:cNvSpPr/>
           <p:nvPr/>
         </p:nvSpPr>
         <p:spPr>
           <a:xfrm>
-            <a:off x="45720" y="6300216"/>
-            <a:ext cx="987551" cy="420624"/>
+            <a:off x="91439" y="6327648"/>
+            <a:ext cx="12033504" cy="493776"/>
           </a:xfrm>
           <a:prstGeom prst="rect">
             <a:avLst/>
           </a:prstGeom>
           <a:solidFill>
-            <a:srgbClr val="FAE0E0"/>
+            <a:srgbClr val="FFFFFF"/>
           </a:solidFill>
-          <a:ln w="10160">
+          <a:ln w="6350">
             <a:solidFill>
-              <a:srgbClr val="CC2222"/>
+              <a:srgbClr val="AAAAAA"/>
             </a:solidFill>
           </a:ln>
         </p:spPr>
@@ -7289,50 +7234,3516 @@
           </a:fontRef>
         </p:style>
         <p:txBody>
+          <a:bodyPr rtlCol="0" anchor="ctr"/>
+          <a:lstStyle/>
+          <a:p>
+            <a:pPr algn="ctr"/>
+          </a:p>
+        </p:txBody>
+      </p:sp>
+      <p:sp>
+        <p:nvSpPr>
+          <p:cNvPr id="70" name="TextBox 69"/>
+          <p:cNvSpPr txBox="1"/>
+          <p:nvPr/>
+        </p:nvSpPr>
+        <p:spPr>
+          <a:xfrm>
+            <a:off x="164592" y="6364224"/>
+            <a:ext cx="914400" cy="164592"/>
+          </a:xfrm>
+          <a:prstGeom prst="rect">
+            <a:avLst/>
+          </a:prstGeom>
+          <a:noFill/>
+        </p:spPr>
+        <p:txBody>
+          <a:bodyPr wrap="square">
+            <a:spAutoFit/>
+          </a:bodyPr>
+          <a:lstStyle/>
+          <a:p>
+            <a:pPr algn="l"/>
+            <a:r>
+              <a:rPr sz="700" b="1" i="0">
+                <a:solidFill>
+                  <a:srgbClr val="222222"/>
+                </a:solidFill>
+              </a:rPr>
+              <a:t>COLOUR CODE</a:t>
+            </a:r>
+          </a:p>
+        </p:txBody>
+      </p:sp>
+      <p:sp>
+        <p:nvSpPr>
+          <p:cNvPr id="71" name="Rectangle 70"/>
+          <p:cNvSpPr/>
+          <p:nvPr/>
+        </p:nvSpPr>
+        <p:spPr>
+          <a:xfrm>
+            <a:off x="164592" y="6565392"/>
+            <a:ext cx="164592" cy="146304"/>
+          </a:xfrm>
+          <a:prstGeom prst="rect">
+            <a:avLst/>
+          </a:prstGeom>
+          <a:solidFill>
+            <a:srgbClr val="176AA0"/>
+          </a:solidFill>
+          <a:ln>
+            <a:solidFill>
+              <a:srgbClr val="176AA0"/>
+            </a:solidFill>
+          </a:ln>
+        </p:spPr>
+        <p:style>
+          <a:lnRef idx="1">
+            <a:schemeClr val="accent1"/>
+          </a:lnRef>
+          <a:fillRef idx="3">
+            <a:schemeClr val="accent1"/>
+          </a:fillRef>
+          <a:effectRef idx="2">
+            <a:schemeClr val="accent1"/>
+          </a:effectRef>
+          <a:fontRef idx="minor">
+            <a:schemeClr val="lt1"/>
+          </a:fontRef>
+        </p:style>
+        <p:txBody>
+          <a:bodyPr rtlCol="0" anchor="ctr"/>
+          <a:lstStyle/>
+          <a:p>
+            <a:pPr algn="ctr"/>
+          </a:p>
+        </p:txBody>
+      </p:sp>
+      <p:sp>
+        <p:nvSpPr>
+          <p:cNvPr id="72" name="TextBox 71"/>
+          <p:cNvSpPr txBox="1"/>
+          <p:nvPr/>
+        </p:nvSpPr>
+        <p:spPr>
+          <a:xfrm>
+            <a:off x="365759" y="6547104"/>
+            <a:ext cx="1389888" cy="182880"/>
+          </a:xfrm>
+          <a:prstGeom prst="rect">
+            <a:avLst/>
+          </a:prstGeom>
+          <a:noFill/>
+        </p:spPr>
+        <p:txBody>
+          <a:bodyPr wrap="square">
+            <a:spAutoFit/>
+          </a:bodyPr>
+          <a:lstStyle/>
+          <a:p>
+            <a:pPr algn="l"/>
+            <a:r>
+              <a:rPr sz="650" b="0" i="0">
+                <a:solidFill>
+                  <a:srgbClr val="222222"/>
+                </a:solidFill>
+              </a:rPr>
+              <a:t>Simulation layer (replay engine)</a:t>
+            </a:r>
+          </a:p>
+        </p:txBody>
+      </p:sp>
+      <p:sp>
+        <p:nvSpPr>
+          <p:cNvPr id="73" name="Rectangle 72"/>
+          <p:cNvSpPr/>
+          <p:nvPr/>
+        </p:nvSpPr>
+        <p:spPr>
+          <a:xfrm>
+            <a:off x="1792224" y="6565392"/>
+            <a:ext cx="164592" cy="146304"/>
+          </a:xfrm>
+          <a:prstGeom prst="rect">
+            <a:avLst/>
+          </a:prstGeom>
+          <a:solidFill>
+            <a:srgbClr val="003399"/>
+          </a:solidFill>
+          <a:ln>
+            <a:solidFill>
+              <a:srgbClr val="003399"/>
+            </a:solidFill>
+          </a:ln>
+        </p:spPr>
+        <p:style>
+          <a:lnRef idx="1">
+            <a:schemeClr val="accent1"/>
+          </a:lnRef>
+          <a:fillRef idx="3">
+            <a:schemeClr val="accent1"/>
+          </a:fillRef>
+          <a:effectRef idx="2">
+            <a:schemeClr val="accent1"/>
+          </a:effectRef>
+          <a:fontRef idx="minor">
+            <a:schemeClr val="lt1"/>
+          </a:fontRef>
+        </p:style>
+        <p:txBody>
+          <a:bodyPr rtlCol="0" anchor="ctr"/>
+          <a:lstStyle/>
+          <a:p>
+            <a:pPr algn="ctr"/>
+          </a:p>
+        </p:txBody>
+      </p:sp>
+      <p:sp>
+        <p:nvSpPr>
+          <p:cNvPr id="74" name="TextBox 73"/>
+          <p:cNvSpPr txBox="1"/>
+          <p:nvPr/>
+        </p:nvSpPr>
+        <p:spPr>
+          <a:xfrm>
+            <a:off x="1993392" y="6547104"/>
+            <a:ext cx="1389888" cy="182880"/>
+          </a:xfrm>
+          <a:prstGeom prst="rect">
+            <a:avLst/>
+          </a:prstGeom>
+          <a:noFill/>
+        </p:spPr>
+        <p:txBody>
+          <a:bodyPr wrap="square">
+            <a:spAutoFit/>
+          </a:bodyPr>
+          <a:lstStyle/>
+          <a:p>
+            <a:pPr algn="l"/>
+            <a:r>
+              <a:rPr sz="650" b="0" i="0">
+                <a:solidFill>
+                  <a:srgbClr val="222222"/>
+                </a:solidFill>
+              </a:rPr>
+              <a:t>EU Custom Data Hub processes</a:t>
+            </a:r>
+          </a:p>
+        </p:txBody>
+      </p:sp>
+      <p:sp>
+        <p:nvSpPr>
+          <p:cNvPr id="75" name="Rectangle 74"/>
+          <p:cNvSpPr/>
+          <p:nvPr/>
+        </p:nvSpPr>
+        <p:spPr>
+          <a:xfrm>
+            <a:off x="3419856" y="6565392"/>
+            <a:ext cx="164592" cy="146304"/>
+          </a:xfrm>
+          <a:prstGeom prst="rect">
+            <a:avLst/>
+          </a:prstGeom>
+          <a:solidFill>
+            <a:srgbClr val="CC2222"/>
+          </a:solidFill>
+          <a:ln>
+            <a:solidFill>
+              <a:srgbClr val="CC2222"/>
+            </a:solidFill>
+          </a:ln>
+        </p:spPr>
+        <p:style>
+          <a:lnRef idx="1">
+            <a:schemeClr val="accent1"/>
+          </a:lnRef>
+          <a:fillRef idx="3">
+            <a:schemeClr val="accent1"/>
+          </a:fillRef>
+          <a:effectRef idx="2">
+            <a:schemeClr val="accent1"/>
+          </a:effectRef>
+          <a:fontRef idx="minor">
+            <a:schemeClr val="lt1"/>
+          </a:fontRef>
+        </p:style>
+        <p:txBody>
+          <a:bodyPr rtlCol="0" anchor="ctr"/>
+          <a:lstStyle/>
+          <a:p>
+            <a:pPr algn="ctr"/>
+          </a:p>
+        </p:txBody>
+      </p:sp>
+      <p:sp>
+        <p:nvSpPr>
+          <p:cNvPr id="76" name="TextBox 75"/>
+          <p:cNvSpPr txBox="1"/>
+          <p:nvPr/>
+        </p:nvSpPr>
+        <p:spPr>
+          <a:xfrm>
+            <a:off x="3621024" y="6547104"/>
+            <a:ext cx="1389888" cy="182880"/>
+          </a:xfrm>
+          <a:prstGeom prst="rect">
+            <a:avLst/>
+          </a:prstGeom>
+          <a:noFill/>
+        </p:spPr>
+        <p:txBody>
+          <a:bodyPr wrap="square">
+            <a:spAutoFit/>
+          </a:bodyPr>
+          <a:lstStyle/>
+          <a:p>
+            <a:pPr algn="l"/>
+            <a:r>
+              <a:rPr sz="650" b="0" i="0">
+                <a:solidFill>
+                  <a:srgbClr val="222222"/>
+                </a:solidFill>
+              </a:rPr>
+              <a:t>VAT alarm detection</a:t>
+            </a:r>
+          </a:p>
+        </p:txBody>
+      </p:sp>
+      <p:sp>
+        <p:nvSpPr>
+          <p:cNvPr id="77" name="Rectangle 76"/>
+          <p:cNvSpPr/>
+          <p:nvPr/>
+        </p:nvSpPr>
+        <p:spPr>
+          <a:xfrm>
+            <a:off x="5047488" y="6565392"/>
+            <a:ext cx="164592" cy="146304"/>
+          </a:xfrm>
+          <a:prstGeom prst="rect">
+            <a:avLst/>
+          </a:prstGeom>
+          <a:solidFill>
+            <a:srgbClr val="6A3D9A"/>
+          </a:solidFill>
+          <a:ln>
+            <a:solidFill>
+              <a:srgbClr val="6A3D9A"/>
+            </a:solidFill>
+          </a:ln>
+        </p:spPr>
+        <p:style>
+          <a:lnRef idx="1">
+            <a:schemeClr val="accent1"/>
+          </a:lnRef>
+          <a:fillRef idx="3">
+            <a:schemeClr val="accent1"/>
+          </a:fillRef>
+          <a:effectRef idx="2">
+            <a:schemeClr val="accent1"/>
+          </a:effectRef>
+          <a:fontRef idx="minor">
+            <a:schemeClr val="lt1"/>
+          </a:fontRef>
+        </p:style>
+        <p:txBody>
+          <a:bodyPr rtlCol="0" anchor="ctr"/>
+          <a:lstStyle/>
+          <a:p>
+            <a:pPr algn="ctr"/>
+          </a:p>
+        </p:txBody>
+      </p:sp>
+      <p:sp>
+        <p:nvSpPr>
+          <p:cNvPr id="78" name="TextBox 77"/>
+          <p:cNvSpPr txBox="1"/>
+          <p:nvPr/>
+        </p:nvSpPr>
+        <p:spPr>
+          <a:xfrm>
+            <a:off x="5248656" y="6547104"/>
+            <a:ext cx="1389888" cy="182880"/>
+          </a:xfrm>
+          <a:prstGeom prst="rect">
+            <a:avLst/>
+          </a:prstGeom>
+          <a:noFill/>
+        </p:spPr>
+        <p:txBody>
+          <a:bodyPr wrap="square">
+            <a:spAutoFit/>
+          </a:bodyPr>
+          <a:lstStyle/>
+          <a:p>
+            <a:pPr algn="l"/>
+            <a:r>
+              <a:rPr sz="650" b="0" i="0">
+                <a:solidFill>
+                  <a:srgbClr val="222222"/>
+                </a:solidFill>
+              </a:rPr>
+              <a:t>AI agent processing</a:t>
+            </a:r>
+          </a:p>
+        </p:txBody>
+      </p:sp>
+      <p:sp>
+        <p:nvSpPr>
+          <p:cNvPr id="79" name="Rectangle 78"/>
+          <p:cNvSpPr/>
+          <p:nvPr/>
+        </p:nvSpPr>
+        <p:spPr>
+          <a:xfrm>
+            <a:off x="6675120" y="6565392"/>
+            <a:ext cx="164592" cy="146304"/>
+          </a:xfrm>
+          <a:prstGeom prst="rect">
+            <a:avLst/>
+          </a:prstGeom>
+          <a:solidFill>
+            <a:srgbClr val="169B62"/>
+          </a:solidFill>
+          <a:ln>
+            <a:solidFill>
+              <a:srgbClr val="169B62"/>
+            </a:solidFill>
+          </a:ln>
+        </p:spPr>
+        <p:style>
+          <a:lnRef idx="1">
+            <a:schemeClr val="accent1"/>
+          </a:lnRef>
+          <a:fillRef idx="3">
+            <a:schemeClr val="accent1"/>
+          </a:fillRef>
+          <a:effectRef idx="2">
+            <a:schemeClr val="accent1"/>
+          </a:effectRef>
+          <a:fontRef idx="minor">
+            <a:schemeClr val="lt1"/>
+          </a:fontRef>
+        </p:style>
+        <p:txBody>
+          <a:bodyPr rtlCol="0" anchor="ctr"/>
+          <a:lstStyle/>
+          <a:p>
+            <a:pPr algn="ctr"/>
+          </a:p>
+        </p:txBody>
+      </p:sp>
+      <p:sp>
+        <p:nvSpPr>
+          <p:cNvPr id="80" name="TextBox 79"/>
+          <p:cNvSpPr txBox="1"/>
+          <p:nvPr/>
+        </p:nvSpPr>
+        <p:spPr>
+          <a:xfrm>
+            <a:off x="6876288" y="6547104"/>
+            <a:ext cx="1389888" cy="182880"/>
+          </a:xfrm>
+          <a:prstGeom prst="rect">
+            <a:avLst/>
+          </a:prstGeom>
+          <a:noFill/>
+        </p:spPr>
+        <p:txBody>
+          <a:bodyPr wrap="square">
+            <a:spAutoFit/>
+          </a:bodyPr>
+          <a:lstStyle/>
+          <a:p>
+            <a:pPr algn="l"/>
+            <a:r>
+              <a:rPr sz="650" b="0" i="0">
+                <a:solidFill>
+                  <a:srgbClr val="222222"/>
+                </a:solidFill>
+              </a:rPr>
+              <a:t>Ireland investigation</a:t>
+            </a:r>
+          </a:p>
+        </p:txBody>
+      </p:sp>
+      <p:sp>
+        <p:nvSpPr>
+          <p:cNvPr id="81" name="Rectangle 80"/>
+          <p:cNvSpPr/>
+          <p:nvPr/>
+        </p:nvSpPr>
+        <p:spPr>
+          <a:xfrm>
+            <a:off x="8302752" y="6565392"/>
+            <a:ext cx="164592" cy="146304"/>
+          </a:xfrm>
+          <a:prstGeom prst="rect">
+            <a:avLst/>
+          </a:prstGeom>
+          <a:solidFill>
+            <a:srgbClr val="007A8A"/>
+          </a:solidFill>
+          <a:ln>
+            <a:solidFill>
+              <a:srgbClr val="007A8A"/>
+            </a:solidFill>
+          </a:ln>
+        </p:spPr>
+        <p:style>
+          <a:lnRef idx="1">
+            <a:schemeClr val="accent1"/>
+          </a:lnRef>
+          <a:fillRef idx="3">
+            <a:schemeClr val="accent1"/>
+          </a:fillRef>
+          <a:effectRef idx="2">
+            <a:schemeClr val="accent1"/>
+          </a:effectRef>
+          <a:fontRef idx="minor">
+            <a:schemeClr val="lt1"/>
+          </a:fontRef>
+        </p:style>
+        <p:txBody>
+          <a:bodyPr rtlCol="0" anchor="ctr"/>
+          <a:lstStyle/>
+          <a:p>
+            <a:pPr algn="ctr"/>
+          </a:p>
+        </p:txBody>
+      </p:sp>
+      <p:sp>
+        <p:nvSpPr>
+          <p:cNvPr id="82" name="TextBox 81"/>
+          <p:cNvSpPr txBox="1"/>
+          <p:nvPr/>
+        </p:nvSpPr>
+        <p:spPr>
+          <a:xfrm>
+            <a:off x="8503919" y="6547104"/>
+            <a:ext cx="1389888" cy="182880"/>
+          </a:xfrm>
+          <a:prstGeom prst="rect">
+            <a:avLst/>
+          </a:prstGeom>
+          <a:noFill/>
+        </p:spPr>
+        <p:txBody>
+          <a:bodyPr wrap="square">
+            <a:spAutoFit/>
+          </a:bodyPr>
+          <a:lstStyle/>
+          <a:p>
+            <a:pPr algn="l"/>
+            <a:r>
+              <a:rPr sz="650" b="0" i="0">
+                <a:solidFill>
+                  <a:srgbClr val="222222"/>
+                </a:solidFill>
+              </a:rPr>
+              <a:t>Persistent database storage</a:t>
+            </a:r>
+          </a:p>
+        </p:txBody>
+      </p:sp>
+      <p:sp>
+        <p:nvSpPr>
+          <p:cNvPr id="83" name="Rectangle 82"/>
+          <p:cNvSpPr/>
+          <p:nvPr/>
+        </p:nvSpPr>
+        <p:spPr>
+          <a:xfrm>
+            <a:off x="9930384" y="6565392"/>
+            <a:ext cx="164592" cy="146304"/>
+          </a:xfrm>
+          <a:prstGeom prst="rect">
+            <a:avLst/>
+          </a:prstGeom>
+          <a:solidFill>
+            <a:srgbClr val="6A3D9A"/>
+          </a:solidFill>
+          <a:ln>
+            <a:solidFill>
+              <a:srgbClr val="6A3D9A"/>
+            </a:solidFill>
+          </a:ln>
+        </p:spPr>
+        <p:style>
+          <a:lnRef idx="1">
+            <a:schemeClr val="accent1"/>
+          </a:lnRef>
+          <a:fillRef idx="3">
+            <a:schemeClr val="accent1"/>
+          </a:fillRef>
+          <a:effectRef idx="2">
+            <a:schemeClr val="accent1"/>
+          </a:effectRef>
+          <a:fontRef idx="minor">
+            <a:schemeClr val="lt1"/>
+          </a:fontRef>
+        </p:style>
+        <p:txBody>
+          <a:bodyPr rtlCol="0" anchor="ctr"/>
+          <a:lstStyle/>
+          <a:p>
+            <a:pPr algn="ctr"/>
+          </a:p>
+        </p:txBody>
+      </p:sp>
+      <p:sp>
+        <p:nvSpPr>
+          <p:cNvPr id="84" name="TextBox 83"/>
+          <p:cNvSpPr txBox="1"/>
+          <p:nvPr/>
+        </p:nvSpPr>
+        <p:spPr>
+          <a:xfrm>
+            <a:off x="10131551" y="6547104"/>
+            <a:ext cx="1389888" cy="182880"/>
+          </a:xfrm>
+          <a:prstGeom prst="rect">
+            <a:avLst/>
+          </a:prstGeom>
+          <a:noFill/>
+        </p:spPr>
+        <p:txBody>
+          <a:bodyPr wrap="square">
+            <a:spAutoFit/>
+          </a:bodyPr>
+          <a:lstStyle/>
+          <a:p>
+            <a:pPr algn="l"/>
+            <a:r>
+              <a:rPr sz="650" b="0" i="0">
+                <a:solidFill>
+                  <a:srgbClr val="222222"/>
+                </a:solidFill>
+              </a:rPr>
+              <a:t>Cross-lane handoff (suspicious IE tx)</a:t>
+            </a:r>
+          </a:p>
+        </p:txBody>
+      </p:sp>
+    </p:spTree>
+  </p:cSld>
+  <p:clrMapOvr>
+    <a:masterClrMapping/>
+  </p:clrMapOvr>
+</p:sld>
+</file>
+
+<file path=ppt/slides/slide2.xml><?xml version="1.0" encoding="utf-8"?>
+<p:sld xmlns:a="http://schemas.openxmlformats.org/drawingml/2006/main" xmlns:p="http://schemas.openxmlformats.org/presentationml/2006/main" xmlns:r="http://schemas.openxmlformats.org/officeDocument/2006/relationships">
+  <p:cSld>
+    <p:bg>
+      <p:bgPr>
+        <a:solidFill>
+          <a:srgbClr val="F0F2F5"/>
+        </a:solidFill>
+        <a:effectLst/>
+      </p:bgPr>
+    </p:bg>
+    <p:spTree>
+      <p:nvGrpSpPr>
+        <p:cNvPr id="1" name=""/>
+        <p:cNvGrpSpPr/>
+        <p:nvPr/>
+      </p:nvGrpSpPr>
+      <p:grpSpPr/>
+      <p:sp>
+        <p:nvSpPr>
+          <p:cNvPr id="2" name="Rectangle 1"/>
+          <p:cNvSpPr/>
+          <p:nvPr/>
+        </p:nvSpPr>
+        <p:spPr>
+          <a:xfrm>
+            <a:off x="0" y="0"/>
+            <a:ext cx="12188952" cy="475488"/>
+          </a:xfrm>
+          <a:prstGeom prst="rect">
+            <a:avLst/>
+          </a:prstGeom>
+          <a:solidFill>
+            <a:srgbClr val="003399"/>
+          </a:solidFill>
+          <a:ln w="12700">
+            <a:solidFill>
+              <a:srgbClr val="003399"/>
+            </a:solidFill>
+          </a:ln>
+        </p:spPr>
+        <p:style>
+          <a:lnRef idx="1">
+            <a:schemeClr val="accent1"/>
+          </a:lnRef>
+          <a:fillRef idx="3">
+            <a:schemeClr val="accent1"/>
+          </a:fillRef>
+          <a:effectRef idx="2">
+            <a:schemeClr val="accent1"/>
+          </a:effectRef>
+          <a:fontRef idx="minor">
+            <a:schemeClr val="lt1"/>
+          </a:fontRef>
+        </p:style>
+        <p:txBody>
           <a:bodyPr rtlCol="0" anchor="ctr" wrap="square"/>
           <a:lstStyle/>
           <a:p>
-            <a:pPr algn="ctr"/>
-            <a:r>
-              <a:rPr sz="650" b="0">
+            <a:pPr algn="l"/>
+            <a:r>
+              <a:rPr sz="1400" b="1">
+                <a:solidFill>
+                  <a:srgbClr val="FFFFFF"/>
+                </a:solidFill>
+              </a:rPr>
+              <a:t>Transaction Journey — Business &amp; Functional Perspective</a:t>
+            </a:r>
+          </a:p>
+        </p:txBody>
+      </p:sp>
+      <p:sp>
+        <p:nvSpPr>
+          <p:cNvPr id="3" name="Rectangle 2"/>
+          <p:cNvSpPr/>
+          <p:nvPr/>
+        </p:nvSpPr>
+        <p:spPr>
+          <a:xfrm>
+            <a:off x="0" y="0"/>
+            <a:ext cx="128016" cy="475488"/>
+          </a:xfrm>
+          <a:prstGeom prst="rect">
+            <a:avLst/>
+          </a:prstGeom>
+          <a:solidFill>
+            <a:srgbClr val="FFED00"/>
+          </a:solidFill>
+          <a:ln w="12700">
+            <a:solidFill>
+              <a:srgbClr val="FFED00"/>
+            </a:solidFill>
+          </a:ln>
+        </p:spPr>
+        <p:style>
+          <a:lnRef idx="1">
+            <a:schemeClr val="accent1"/>
+          </a:lnRef>
+          <a:fillRef idx="3">
+            <a:schemeClr val="accent1"/>
+          </a:fillRef>
+          <a:effectRef idx="2">
+            <a:schemeClr val="accent1"/>
+          </a:effectRef>
+          <a:fontRef idx="minor">
+            <a:schemeClr val="lt1"/>
+          </a:fontRef>
+        </p:style>
+        <p:txBody>
+          <a:bodyPr rtlCol="0" anchor="ctr"/>
+          <a:lstStyle/>
+          <a:p>
+            <a:pPr algn="ctr"/>
+          </a:p>
+        </p:txBody>
+      </p:sp>
+      <p:sp>
+        <p:nvSpPr>
+          <p:cNvPr id="4" name="Rectangle 3"/>
+          <p:cNvSpPr/>
+          <p:nvPr/>
+        </p:nvSpPr>
+        <p:spPr>
+          <a:xfrm>
+            <a:off x="137160" y="530352"/>
+            <a:ext cx="11914632" cy="310896"/>
+          </a:xfrm>
+          <a:prstGeom prst="rect">
+            <a:avLst/>
+          </a:prstGeom>
+          <a:solidFill>
+            <a:srgbClr val="D4DFF2"/>
+          </a:solidFill>
+          <a:ln w="10160">
+            <a:solidFill>
+              <a:srgbClr val="003399"/>
+            </a:solidFill>
+          </a:ln>
+        </p:spPr>
+        <p:style>
+          <a:lnRef idx="1">
+            <a:schemeClr val="accent1"/>
+          </a:lnRef>
+          <a:fillRef idx="3">
+            <a:schemeClr val="accent1"/>
+          </a:fillRef>
+          <a:effectRef idx="2">
+            <a:schemeClr val="accent1"/>
+          </a:effectRef>
+          <a:fontRef idx="minor">
+            <a:schemeClr val="lt1"/>
+          </a:fontRef>
+        </p:style>
+        <p:txBody>
+          <a:bodyPr rtlCol="0" anchor="ctr" wrap="square"/>
+          <a:lstStyle/>
+          <a:p>
+            <a:pPr algn="l"/>
+            <a:r>
+              <a:rPr sz="850" b="0">
+                <a:solidFill>
+                  <a:srgbClr val="003399"/>
+                </a:solidFill>
+              </a:rPr>
+              <a:t>Cross-border B2C e-commerce transaction (supplier → EU buyer) arrives at the EU Custom Data Hub carrying: seller identity, buyer country, product category, value, and applied VAT rate.</a:t>
+            </a:r>
+          </a:p>
+        </p:txBody>
+      </p:sp>
+      <p:sp>
+        <p:nvSpPr>
+          <p:cNvPr id="5" name="Rectangle 4"/>
+          <p:cNvSpPr/>
+          <p:nvPr/>
+        </p:nvSpPr>
+        <p:spPr>
+          <a:xfrm>
+            <a:off x="109728" y="1856232"/>
+            <a:ext cx="1207008" cy="1115568"/>
+          </a:xfrm>
+          <a:prstGeom prst="rect">
+            <a:avLst/>
+          </a:prstGeom>
+          <a:solidFill>
+            <a:srgbClr val="D4DFF2"/>
+          </a:solidFill>
+          <a:ln w="25400">
+            <a:solidFill>
+              <a:srgbClr val="003399"/>
+            </a:solidFill>
+          </a:ln>
+        </p:spPr>
+        <p:style>
+          <a:lnRef idx="1">
+            <a:schemeClr val="accent1"/>
+          </a:lnRef>
+          <a:fillRef idx="3">
+            <a:schemeClr val="accent1"/>
+          </a:fillRef>
+          <a:effectRef idx="2">
+            <a:schemeClr val="accent1"/>
+          </a:effectRef>
+          <a:fontRef idx="minor">
+            <a:schemeClr val="lt1"/>
+          </a:fontRef>
+        </p:style>
+        <p:txBody>
+          <a:bodyPr rtlCol="0" anchor="ctr" wrap="square"/>
+          <a:lstStyle/>
+          <a:p>
+            <a:pPr algn="ctr"/>
+            <a:r>
+              <a:rPr sz="950" b="1">
+                <a:solidFill>
+                  <a:srgbClr val="003399"/>
+                </a:solidFill>
+              </a:rPr>
+              <a:t>Transaction</a:t>
+            </a:r>
+          </a:p>
+          <a:p>
+            <a:pPr algn="ctr"/>
+            <a:r>
+              <a:rPr sz="950" b="1">
+                <a:solidFill>
+                  <a:srgbClr val="003399"/>
+                </a:solidFill>
+              </a:rPr>
+              <a:t>Arrives</a:t>
+            </a:r>
+          </a:p>
+          <a:p>
+            <a:pPr algn="ctr"/>
+            <a:r>
+              <a:rPr sz="950" b="1">
+                <a:solidFill>
+                  <a:srgbClr val="003399"/>
+                </a:solidFill>
+              </a:rPr>
+              <a:t>at EU Custom</a:t>
+            </a:r>
+          </a:p>
+          <a:p>
+            <a:pPr algn="ctr"/>
+            <a:r>
+              <a:rPr sz="950" b="1">
+                <a:solidFill>
+                  <a:srgbClr val="003399"/>
+                </a:solidFill>
+              </a:rPr>
+              <a:t>Data Hub</a:t>
+            </a:r>
+          </a:p>
+        </p:txBody>
+      </p:sp>
+      <p:sp>
+        <p:nvSpPr>
+          <p:cNvPr id="6" name="Rectangle 5"/>
+          <p:cNvSpPr/>
+          <p:nvPr/>
+        </p:nvSpPr>
+        <p:spPr>
+          <a:xfrm>
+            <a:off x="109728" y="1618488"/>
+            <a:ext cx="1207008" cy="201168"/>
+          </a:xfrm>
+          <a:prstGeom prst="rect">
+            <a:avLst/>
+          </a:prstGeom>
+          <a:solidFill>
+            <a:srgbClr val="003399"/>
+          </a:solidFill>
+          <a:ln>
+            <a:solidFill>
+              <a:srgbClr val="003399"/>
+            </a:solidFill>
+          </a:ln>
+        </p:spPr>
+        <p:style>
+          <a:lnRef idx="1">
+            <a:schemeClr val="accent1"/>
+          </a:lnRef>
+          <a:fillRef idx="3">
+            <a:schemeClr val="accent1"/>
+          </a:fillRef>
+          <a:effectRef idx="2">
+            <a:schemeClr val="accent1"/>
+          </a:effectRef>
+          <a:fontRef idx="minor">
+            <a:schemeClr val="lt1"/>
+          </a:fontRef>
+        </p:style>
+        <p:txBody>
+          <a:bodyPr rtlCol="0" anchor="ctr" wrap="square"/>
+          <a:lstStyle/>
+          <a:p>
+            <a:pPr algn="ctr"/>
+            <a:r>
+              <a:rPr sz="650" b="1">
+                <a:solidFill>
+                  <a:srgbClr val="FFFFFF"/>
+                </a:solidFill>
+              </a:rPr>
+              <a:t>Supplier (cross-border B2C)</a:t>
+            </a:r>
+          </a:p>
+        </p:txBody>
+      </p:sp>
+      <p:sp>
+        <p:nvSpPr>
+          <p:cNvPr id="7" name="Rectangle 6"/>
+          <p:cNvSpPr/>
+          <p:nvPr/>
+        </p:nvSpPr>
+        <p:spPr>
+          <a:xfrm>
+            <a:off x="1517904" y="1856232"/>
+            <a:ext cx="1207008" cy="1115568"/>
+          </a:xfrm>
+          <a:prstGeom prst="rect">
+            <a:avLst/>
+          </a:prstGeom>
+          <a:solidFill>
+            <a:srgbClr val="D4DFF2"/>
+          </a:solidFill>
+          <a:ln w="25400">
+            <a:solidFill>
+              <a:srgbClr val="003399"/>
+            </a:solidFill>
+          </a:ln>
+        </p:spPr>
+        <p:style>
+          <a:lnRef idx="1">
+            <a:schemeClr val="accent1"/>
+          </a:lnRef>
+          <a:fillRef idx="3">
+            <a:schemeClr val="accent1"/>
+          </a:fillRef>
+          <a:effectRef idx="2">
+            <a:schemeClr val="accent1"/>
+          </a:effectRef>
+          <a:fontRef idx="minor">
+            <a:schemeClr val="lt1"/>
+          </a:fontRef>
+        </p:style>
+        <p:txBody>
+          <a:bodyPr rtlCol="0" anchor="ctr" wrap="square"/>
+          <a:lstStyle/>
+          <a:p>
+            <a:pPr algn="ctr"/>
+            <a:r>
+              <a:rPr sz="950" b="1">
+                <a:solidFill>
+                  <a:srgbClr val="003399"/>
+                </a:solidFill>
+              </a:rPr>
+              <a:t>Transaction</a:t>
+            </a:r>
+          </a:p>
+          <a:p>
+            <a:pPr algn="ctr"/>
+            <a:r>
+              <a:rPr sz="950" b="1">
+                <a:solidFill>
+                  <a:srgbClr val="003399"/>
+                </a:solidFill>
+              </a:rPr>
+              <a:t>Recorded</a:t>
+            </a:r>
+          </a:p>
+          <a:p>
+            <a:pPr algn="ctr"/>
+            <a:r>
+              <a:rPr sz="950" b="1">
+                <a:solidFill>
+                  <a:srgbClr val="003399"/>
+                </a:solidFill>
+              </a:rPr>
+              <a:t>Permanently</a:t>
+            </a:r>
+          </a:p>
+        </p:txBody>
+      </p:sp>
+      <p:sp>
+        <p:nvSpPr>
+          <p:cNvPr id="8" name="TextBox 7"/>
+          <p:cNvSpPr txBox="1"/>
+          <p:nvPr/>
+        </p:nvSpPr>
+        <p:spPr>
+          <a:xfrm>
+            <a:off x="1591056" y="2547884"/>
+            <a:ext cx="1060704" cy="274320"/>
+          </a:xfrm>
+          <a:prstGeom prst="rect">
+            <a:avLst/>
+          </a:prstGeom>
+          <a:noFill/>
+        </p:spPr>
+        <p:txBody>
+          <a:bodyPr wrap="square">
+            <a:spAutoFit/>
+          </a:bodyPr>
+          <a:lstStyle/>
+          <a:p>
+            <a:pPr algn="ctr"/>
+            <a:r>
+              <a:rPr sz="700" b="0" i="1">
+                <a:solidFill>
+                  <a:srgbClr val="003399"/>
+                </a:solidFill>
+              </a:rPr>
+              <a:t>Regardless of</a:t>
+            </a:r>
+          </a:p>
+          <a:p>
+            <a:pPr algn="ctr"/>
+            <a:r>
+              <a:rPr sz="700" b="0" i="1">
+                <a:solidFill>
+                  <a:srgbClr val="003399"/>
+                </a:solidFill>
+              </a:rPr>
+              <a:t>compliance status</a:t>
+            </a:r>
+          </a:p>
+        </p:txBody>
+      </p:sp>
+      <p:sp>
+        <p:nvSpPr>
+          <p:cNvPr id="9" name="Rectangle 8"/>
+          <p:cNvSpPr/>
+          <p:nvPr/>
+        </p:nvSpPr>
+        <p:spPr>
+          <a:xfrm>
+            <a:off x="1517904" y="1618488"/>
+            <a:ext cx="1207008" cy="201168"/>
+          </a:xfrm>
+          <a:prstGeom prst="rect">
+            <a:avLst/>
+          </a:prstGeom>
+          <a:solidFill>
+            <a:srgbClr val="003399"/>
+          </a:solidFill>
+          <a:ln>
+            <a:solidFill>
+              <a:srgbClr val="003399"/>
+            </a:solidFill>
+          </a:ln>
+        </p:spPr>
+        <p:style>
+          <a:lnRef idx="1">
+            <a:schemeClr val="accent1"/>
+          </a:lnRef>
+          <a:fillRef idx="3">
+            <a:schemeClr val="accent1"/>
+          </a:fillRef>
+          <a:effectRef idx="2">
+            <a:schemeClr val="accent1"/>
+          </a:effectRef>
+          <a:fontRef idx="minor">
+            <a:schemeClr val="lt1"/>
+          </a:fontRef>
+        </p:style>
+        <p:txBody>
+          <a:bodyPr rtlCol="0" anchor="ctr" wrap="square"/>
+          <a:lstStyle/>
+          <a:p>
+            <a:pPr algn="ctr"/>
+            <a:r>
+              <a:rPr sz="650" b="1">
+                <a:solidFill>
+                  <a:srgbClr val="FFFFFF"/>
+                </a:solidFill>
+              </a:rPr>
+              <a:t>EU Custom Data Hub</a:t>
+            </a:r>
+          </a:p>
+        </p:txBody>
+      </p:sp>
+      <p:sp>
+        <p:nvSpPr>
+          <p:cNvPr id="10" name="Rectangle 9"/>
+          <p:cNvSpPr/>
+          <p:nvPr/>
+        </p:nvSpPr>
+        <p:spPr>
+          <a:xfrm>
+            <a:off x="2926080" y="1856232"/>
+            <a:ext cx="1207008" cy="1115568"/>
+          </a:xfrm>
+          <a:prstGeom prst="rect">
+            <a:avLst/>
+          </a:prstGeom>
+          <a:solidFill>
+            <a:srgbClr val="D4DFF2"/>
+          </a:solidFill>
+          <a:ln w="25400">
+            <a:solidFill>
+              <a:srgbClr val="003399"/>
+            </a:solidFill>
+          </a:ln>
+        </p:spPr>
+        <p:style>
+          <a:lnRef idx="1">
+            <a:schemeClr val="accent1"/>
+          </a:lnRef>
+          <a:fillRef idx="3">
+            <a:schemeClr val="accent1"/>
+          </a:fillRef>
+          <a:effectRef idx="2">
+            <a:schemeClr val="accent1"/>
+          </a:effectRef>
+          <a:fontRef idx="minor">
+            <a:schemeClr val="lt1"/>
+          </a:fontRef>
+        </p:style>
+        <p:txBody>
+          <a:bodyPr rtlCol="0" anchor="ctr" wrap="square"/>
+          <a:lstStyle/>
+          <a:p>
+            <a:pPr algn="ctr"/>
+            <a:r>
+              <a:rPr sz="950" b="1">
+                <a:solidFill>
+                  <a:srgbClr val="003399"/>
+                </a:solidFill>
+              </a:rPr>
+              <a:t>VAT Compliance</a:t>
+            </a:r>
+          </a:p>
+          <a:p>
+            <a:pPr algn="ctr"/>
+            <a:r>
+              <a:rPr sz="950" b="1">
+                <a:solidFill>
+                  <a:srgbClr val="003399"/>
+                </a:solidFill>
+              </a:rPr>
+              <a:t>Monitoring</a:t>
+            </a:r>
+          </a:p>
+          <a:p>
+            <a:pPr algn="ctr"/>
+            <a:r>
+              <a:rPr sz="950" b="1">
+                <a:solidFill>
+                  <a:srgbClr val="003399"/>
+                </a:solidFill>
+              </a:rPr>
+              <a:t>(automated)</a:t>
+            </a:r>
+          </a:p>
+        </p:txBody>
+      </p:sp>
+      <p:sp>
+        <p:nvSpPr>
+          <p:cNvPr id="11" name="TextBox 10"/>
+          <p:cNvSpPr txBox="1"/>
+          <p:nvPr/>
+        </p:nvSpPr>
+        <p:spPr>
+          <a:xfrm>
+            <a:off x="2999232" y="2547884"/>
+            <a:ext cx="1060704" cy="274320"/>
+          </a:xfrm>
+          <a:prstGeom prst="rect">
+            <a:avLst/>
+          </a:prstGeom>
+          <a:noFill/>
+        </p:spPr>
+        <p:txBody>
+          <a:bodyPr wrap="square">
+            <a:spAutoFit/>
+          </a:bodyPr>
+          <a:lstStyle/>
+          <a:p>
+            <a:pPr algn="ctr"/>
+            <a:r>
+              <a:rPr sz="700" b="0" i="1">
+                <a:solidFill>
+                  <a:srgbClr val="003399"/>
+                </a:solidFill>
+              </a:rPr>
+              <a:t>7-day ratio vs</a:t>
+            </a:r>
+          </a:p>
+          <a:p>
+            <a:pPr algn="ctr"/>
+            <a:r>
+              <a:rPr sz="700" b="0" i="1">
+                <a:solidFill>
+                  <a:srgbClr val="003399"/>
+                </a:solidFill>
+              </a:rPr>
+              <a:t>8-week baseline</a:t>
+            </a:r>
+          </a:p>
+        </p:txBody>
+      </p:sp>
+      <p:sp>
+        <p:nvSpPr>
+          <p:cNvPr id="12" name="Rectangle 11"/>
+          <p:cNvSpPr/>
+          <p:nvPr/>
+        </p:nvSpPr>
+        <p:spPr>
+          <a:xfrm>
+            <a:off x="2926080" y="1618488"/>
+            <a:ext cx="1207008" cy="201168"/>
+          </a:xfrm>
+          <a:prstGeom prst="rect">
+            <a:avLst/>
+          </a:prstGeom>
+          <a:solidFill>
+            <a:srgbClr val="003399"/>
+          </a:solidFill>
+          <a:ln>
+            <a:solidFill>
+              <a:srgbClr val="003399"/>
+            </a:solidFill>
+          </a:ln>
+        </p:spPr>
+        <p:style>
+          <a:lnRef idx="1">
+            <a:schemeClr val="accent1"/>
+          </a:lnRef>
+          <a:fillRef idx="3">
+            <a:schemeClr val="accent1"/>
+          </a:fillRef>
+          <a:effectRef idx="2">
+            <a:schemeClr val="accent1"/>
+          </a:effectRef>
+          <a:fontRef idx="minor">
+            <a:schemeClr val="lt1"/>
+          </a:fontRef>
+        </p:style>
+        <p:txBody>
+          <a:bodyPr rtlCol="0" anchor="ctr" wrap="square"/>
+          <a:lstStyle/>
+          <a:p>
+            <a:pPr algn="ctr"/>
+            <a:r>
+              <a:rPr sz="650" b="1">
+                <a:solidFill>
+                  <a:srgbClr val="FFFFFF"/>
+                </a:solidFill>
+              </a:rPr>
+              <a:t>EU Custom Data Hub</a:t>
+            </a:r>
+          </a:p>
+        </p:txBody>
+      </p:sp>
+      <p:sp>
+        <p:nvSpPr>
+          <p:cNvPr id="13" name="Diamond 12"/>
+          <p:cNvSpPr/>
+          <p:nvPr/>
+        </p:nvSpPr>
+        <p:spPr>
+          <a:xfrm>
+            <a:off x="4334256" y="1911095"/>
+            <a:ext cx="1042415" cy="1005840"/>
+          </a:xfrm>
+          <a:prstGeom prst="diamond">
+            <a:avLst/>
+          </a:prstGeom>
+          <a:solidFill>
+            <a:srgbClr val="FDF0D8"/>
+          </a:solidFill>
+          <a:ln w="25400">
+            <a:solidFill>
+              <a:srgbClr val="E68A00"/>
+            </a:solidFill>
+          </a:ln>
+        </p:spPr>
+        <p:style>
+          <a:lnRef idx="1">
+            <a:schemeClr val="accent1"/>
+          </a:lnRef>
+          <a:fillRef idx="3">
+            <a:schemeClr val="accent1"/>
+          </a:fillRef>
+          <a:effectRef idx="2">
+            <a:schemeClr val="accent1"/>
+          </a:effectRef>
+          <a:fontRef idx="minor">
+            <a:schemeClr val="lt1"/>
+          </a:fontRef>
+        </p:style>
+        <p:txBody>
+          <a:bodyPr rtlCol="0" anchor="ctr" wrap="square"/>
+          <a:lstStyle/>
+          <a:p>
+            <a:pPr algn="ctr"/>
+            <a:r>
+              <a:rPr sz="850" b="1">
+                <a:solidFill>
+                  <a:srgbClr val="E68A00"/>
+                </a:solidFill>
+              </a:rPr>
+              <a:t>VAT Rate</a:t>
+            </a:r>
+          </a:p>
+          <a:p>
+            <a:pPr algn="ctr"/>
+            <a:r>
+              <a:rPr sz="850" b="1">
+                <a:solidFill>
+                  <a:srgbClr val="E68A00"/>
+                </a:solidFill>
+              </a:rPr>
+              <a:t>Deviation</a:t>
+            </a:r>
+          </a:p>
+          <a:p>
+            <a:pPr algn="ctr"/>
+            <a:r>
+              <a:rPr sz="850" b="1">
+                <a:solidFill>
+                  <a:srgbClr val="E68A00"/>
+                </a:solidFill>
+              </a:rPr>
+              <a:t>Alert?</a:t>
+            </a:r>
+          </a:p>
+        </p:txBody>
+      </p:sp>
+      <p:sp>
+        <p:nvSpPr>
+          <p:cNvPr id="14" name="Rectangle 13"/>
+          <p:cNvSpPr/>
+          <p:nvPr/>
+        </p:nvSpPr>
+        <p:spPr>
+          <a:xfrm>
+            <a:off x="5577840" y="1856232"/>
+            <a:ext cx="1207008" cy="1115568"/>
+          </a:xfrm>
+          <a:prstGeom prst="rect">
+            <a:avLst/>
+          </a:prstGeom>
+          <a:solidFill>
+            <a:srgbClr val="FAE0E0"/>
+          </a:solidFill>
+          <a:ln w="25400">
+            <a:solidFill>
+              <a:srgbClr val="CC2222"/>
+            </a:solidFill>
+          </a:ln>
+        </p:spPr>
+        <p:style>
+          <a:lnRef idx="1">
+            <a:schemeClr val="accent1"/>
+          </a:lnRef>
+          <a:fillRef idx="3">
+            <a:schemeClr val="accent1"/>
+          </a:fillRef>
+          <a:effectRef idx="2">
+            <a:schemeClr val="accent1"/>
+          </a:effectRef>
+          <a:fontRef idx="minor">
+            <a:schemeClr val="lt1"/>
+          </a:fontRef>
+        </p:style>
+        <p:txBody>
+          <a:bodyPr rtlCol="0" anchor="ctr" wrap="square"/>
+          <a:lstStyle/>
+          <a:p>
+            <a:pPr algn="ctr"/>
+            <a:r>
+              <a:rPr sz="950" b="1">
                 <a:solidFill>
                   <a:srgbClr val="CC2222"/>
                 </a:solidFill>
               </a:rPr>
-              <a:t>MEDIUM</a:t>
-            </a:r>
-          </a:p>
-          <a:p>
-            <a:pPr algn="ctr"/>
-            <a:r>
-              <a:rPr sz="650" b="0">
+              <a:t>Deviation Alert</a:t>
+            </a:r>
+          </a:p>
+          <a:p>
+            <a:pPr algn="ctr"/>
+            <a:r>
+              <a:rPr sz="950" b="1">
                 <a:solidFill>
                   <a:srgbClr val="CC2222"/>
                 </a:solidFill>
               </a:rPr>
-              <a:t>→ alarm</a:t>
-            </a:r>
-          </a:p>
-          <a:p>
-            <a:pPr algn="ctr"/>
-            <a:r>
-              <a:rPr sz="650" b="0">
+              <a:t>Raised</a:t>
+            </a:r>
+          </a:p>
+          <a:p>
+            <a:pPr algn="ctr"/>
+            <a:r>
+              <a:rPr sz="950" b="1">
                 <a:solidFill>
                   <a:srgbClr val="CC2222"/>
                 </a:solidFill>
               </a:rPr>
-              <a:t>HIGH</a:t>
-            </a:r>
-          </a:p>
-          <a:p>
-            <a:pPr algn="ctr"/>
-            <a:r>
-              <a:rPr sz="650" b="0">
+              <a:t>(7-day validity)</a:t>
+            </a:r>
+          </a:p>
+        </p:txBody>
+      </p:sp>
+      <p:sp>
+        <p:nvSpPr>
+          <p:cNvPr id="15" name="TextBox 14"/>
+          <p:cNvSpPr txBox="1"/>
+          <p:nvPr/>
+        </p:nvSpPr>
+        <p:spPr>
+          <a:xfrm>
+            <a:off x="5650992" y="2547884"/>
+            <a:ext cx="1060704" cy="274320"/>
+          </a:xfrm>
+          <a:prstGeom prst="rect">
+            <a:avLst/>
+          </a:prstGeom>
+          <a:noFill/>
+        </p:spPr>
+        <p:txBody>
+          <a:bodyPr wrap="square">
+            <a:spAutoFit/>
+          </a:bodyPr>
+          <a:lstStyle/>
+          <a:p>
+            <a:pPr algn="ctr"/>
+            <a:r>
+              <a:rPr sz="700" b="0" i="1">
                 <a:solidFill>
                   <a:srgbClr val="CC2222"/>
                 </a:solidFill>
               </a:rPr>
-              <a:t>→ agent</a:t>
+              <a:t>Supplier flagged for</a:t>
+            </a:r>
+          </a:p>
+          <a:p>
+            <a:pPr algn="ctr"/>
+            <a:r>
+              <a:rPr sz="700" b="0" i="1">
+                <a:solidFill>
+                  <a:srgbClr val="CC2222"/>
+                </a:solidFill>
+              </a:rPr>
+              <a:t>enhanced monitoring</a:t>
+            </a:r>
+          </a:p>
+        </p:txBody>
+      </p:sp>
+      <p:sp>
+        <p:nvSpPr>
+          <p:cNvPr id="16" name="Rectangle 15"/>
+          <p:cNvSpPr/>
+          <p:nvPr/>
+        </p:nvSpPr>
+        <p:spPr>
+          <a:xfrm>
+            <a:off x="5577840" y="3008376"/>
+            <a:ext cx="1207008" cy="201168"/>
+          </a:xfrm>
+          <a:prstGeom prst="rect">
+            <a:avLst/>
+          </a:prstGeom>
+          <a:solidFill>
+            <a:srgbClr val="CC2222"/>
+          </a:solidFill>
+          <a:ln>
+            <a:solidFill>
+              <a:srgbClr val="CC2222"/>
+            </a:solidFill>
+          </a:ln>
+        </p:spPr>
+        <p:style>
+          <a:lnRef idx="1">
+            <a:schemeClr val="accent1"/>
+          </a:lnRef>
+          <a:fillRef idx="3">
+            <a:schemeClr val="accent1"/>
+          </a:fillRef>
+          <a:effectRef idx="2">
+            <a:schemeClr val="accent1"/>
+          </a:effectRef>
+          <a:fontRef idx="minor">
+            <a:schemeClr val="lt1"/>
+          </a:fontRef>
+        </p:style>
+        <p:txBody>
+          <a:bodyPr rtlCol="0" anchor="ctr" wrap="square"/>
+          <a:lstStyle/>
+          <a:p>
+            <a:pPr algn="ctr"/>
+            <a:r>
+              <a:rPr sz="650" b="1">
+                <a:solidFill>
+                  <a:srgbClr val="FFFFFF"/>
+                </a:solidFill>
+              </a:rPr>
+              <a:t>Suspicion: MEDIUM</a:t>
+            </a:r>
+          </a:p>
+        </p:txBody>
+      </p:sp>
+      <p:sp>
+        <p:nvSpPr>
+          <p:cNvPr id="17" name="Diamond 16"/>
+          <p:cNvSpPr/>
+          <p:nvPr/>
+        </p:nvSpPr>
+        <p:spPr>
+          <a:xfrm>
+            <a:off x="6986016" y="1911095"/>
+            <a:ext cx="1042415" cy="1005840"/>
+          </a:xfrm>
+          <a:prstGeom prst="diamond">
+            <a:avLst/>
+          </a:prstGeom>
+          <a:solidFill>
+            <a:srgbClr val="FDF0D8"/>
+          </a:solidFill>
+          <a:ln w="25400">
+            <a:solidFill>
+              <a:srgbClr val="E68A00"/>
+            </a:solidFill>
+          </a:ln>
+        </p:spPr>
+        <p:style>
+          <a:lnRef idx="1">
+            <a:schemeClr val="accent1"/>
+          </a:lnRef>
+          <a:fillRef idx="3">
+            <a:schemeClr val="accent1"/>
+          </a:fillRef>
+          <a:effectRef idx="2">
+            <a:schemeClr val="accent1"/>
+          </a:effectRef>
+          <a:fontRef idx="minor">
+            <a:schemeClr val="lt1"/>
+          </a:fontRef>
+        </p:style>
+        <p:txBody>
+          <a:bodyPr rtlCol="0" anchor="ctr" wrap="square"/>
+          <a:lstStyle/>
+          <a:p>
+            <a:pPr algn="ctr"/>
+            <a:r>
+              <a:rPr sz="850" b="1">
+                <a:solidFill>
+                  <a:srgbClr val="E68A00"/>
+                </a:solidFill>
+              </a:rPr>
+              <a:t>Destination:</a:t>
+            </a:r>
+          </a:p>
+          <a:p>
+            <a:pPr algn="ctr"/>
+            <a:r>
+              <a:rPr sz="850" b="1">
+                <a:solidFill>
+                  <a:srgbClr val="E68A00"/>
+                </a:solidFill>
+              </a:rPr>
+              <a:t>Ireland?</a:t>
+            </a:r>
+          </a:p>
+        </p:txBody>
+      </p:sp>
+      <p:sp>
+        <p:nvSpPr>
+          <p:cNvPr id="18" name="Rectangle 17"/>
+          <p:cNvSpPr/>
+          <p:nvPr/>
+        </p:nvSpPr>
+        <p:spPr>
+          <a:xfrm>
+            <a:off x="8229600" y="1856232"/>
+            <a:ext cx="1207008" cy="1115568"/>
+          </a:xfrm>
+          <a:prstGeom prst="rect">
+            <a:avLst/>
+          </a:prstGeom>
+          <a:solidFill>
+            <a:srgbClr val="E8DDF5"/>
+          </a:solidFill>
+          <a:ln w="25400">
+            <a:solidFill>
+              <a:srgbClr val="6A3D9A"/>
+            </a:solidFill>
+          </a:ln>
+        </p:spPr>
+        <p:style>
+          <a:lnRef idx="1">
+            <a:schemeClr val="accent1"/>
+          </a:lnRef>
+          <a:fillRef idx="3">
+            <a:schemeClr val="accent1"/>
+          </a:fillRef>
+          <a:effectRef idx="2">
+            <a:schemeClr val="accent1"/>
+          </a:effectRef>
+          <a:fontRef idx="minor">
+            <a:schemeClr val="lt1"/>
+          </a:fontRef>
+        </p:style>
+        <p:txBody>
+          <a:bodyPr rtlCol="0" anchor="ctr" wrap="square"/>
+          <a:lstStyle/>
+          <a:p>
+            <a:pPr algn="ctr"/>
+            <a:r>
+              <a:rPr sz="950" b="1">
+                <a:solidFill>
+                  <a:srgbClr val="6A3D9A"/>
+                </a:solidFill>
+              </a:rPr>
+              <a:t>AI Compliance</a:t>
+            </a:r>
+          </a:p>
+          <a:p>
+            <a:pPr algn="ctr"/>
+            <a:r>
+              <a:rPr sz="950" b="1">
+                <a:solidFill>
+                  <a:srgbClr val="6A3D9A"/>
+                </a:solidFill>
+              </a:rPr>
+              <a:t>Agent</a:t>
+            </a:r>
+          </a:p>
+          <a:p>
+            <a:pPr algn="ctr"/>
+            <a:r>
+              <a:rPr sz="950" b="1">
+                <a:solidFill>
+                  <a:srgbClr val="6A3D9A"/>
+                </a:solidFill>
+              </a:rPr>
+              <a:t>Analysis</a:t>
+            </a:r>
+          </a:p>
+        </p:txBody>
+      </p:sp>
+      <p:sp>
+        <p:nvSpPr>
+          <p:cNvPr id="19" name="TextBox 18"/>
+          <p:cNvSpPr txBox="1"/>
+          <p:nvPr/>
+        </p:nvSpPr>
+        <p:spPr>
+          <a:xfrm>
+            <a:off x="8302752" y="2480950"/>
+            <a:ext cx="1060704" cy="347472"/>
+          </a:xfrm>
+          <a:prstGeom prst="rect">
+            <a:avLst/>
+          </a:prstGeom>
+          <a:noFill/>
+        </p:spPr>
+        <p:txBody>
+          <a:bodyPr wrap="square">
+            <a:spAutoFit/>
+          </a:bodyPr>
+          <a:lstStyle/>
+          <a:p>
+            <a:pPr algn="ctr"/>
+            <a:r>
+              <a:rPr sz="700" b="0" i="1">
+                <a:solidFill>
+                  <a:srgbClr val="6A3D9A"/>
+                </a:solidFill>
+              </a:rPr>
+              <a:t>VAT legislation RAG</a:t>
+            </a:r>
+          </a:p>
+          <a:p>
+            <a:pPr algn="ctr"/>
+            <a:r>
+              <a:rPr sz="700" b="0" i="1">
+                <a:solidFill>
+                  <a:srgbClr val="6A3D9A"/>
+                </a:solidFill>
+              </a:rPr>
+              <a:t>+ LLM verdict</a:t>
+            </a:r>
+          </a:p>
+          <a:p>
+            <a:pPr algn="ctr"/>
+            <a:r>
+              <a:rPr sz="700" b="0" i="1">
+                <a:solidFill>
+                  <a:srgbClr val="6A3D9A"/>
+                </a:solidFill>
+              </a:rPr>
+              <a:t>per line item</a:t>
+            </a:r>
+          </a:p>
+        </p:txBody>
+      </p:sp>
+      <p:sp>
+        <p:nvSpPr>
+          <p:cNvPr id="20" name="Rectangle 19"/>
+          <p:cNvSpPr/>
+          <p:nvPr/>
+        </p:nvSpPr>
+        <p:spPr>
+          <a:xfrm>
+            <a:off x="8229600" y="1618488"/>
+            <a:ext cx="1207008" cy="201168"/>
+          </a:xfrm>
+          <a:prstGeom prst="rect">
+            <a:avLst/>
+          </a:prstGeom>
+          <a:solidFill>
+            <a:srgbClr val="6A3D9A"/>
+          </a:solidFill>
+          <a:ln>
+            <a:solidFill>
+              <a:srgbClr val="6A3D9A"/>
+            </a:solidFill>
+          </a:ln>
+        </p:spPr>
+        <p:style>
+          <a:lnRef idx="1">
+            <a:schemeClr val="accent1"/>
+          </a:lnRef>
+          <a:fillRef idx="3">
+            <a:schemeClr val="accent1"/>
+          </a:fillRef>
+          <a:effectRef idx="2">
+            <a:schemeClr val="accent1"/>
+          </a:effectRef>
+          <a:fontRef idx="minor">
+            <a:schemeClr val="lt1"/>
+          </a:fontRef>
+        </p:style>
+        <p:txBody>
+          <a:bodyPr rtlCol="0" anchor="ctr" wrap="square"/>
+          <a:lstStyle/>
+          <a:p>
+            <a:pPr algn="ctr"/>
+            <a:r>
+              <a:rPr sz="650" b="1">
+                <a:solidFill>
+                  <a:srgbClr val="FFFFFF"/>
+                </a:solidFill>
+              </a:rPr>
+              <a:t>EU Customs → Irish Revenue Agent</a:t>
+            </a:r>
+          </a:p>
+        </p:txBody>
+      </p:sp>
+      <p:sp>
+        <p:nvSpPr>
+          <p:cNvPr id="21" name="Diamond 20"/>
+          <p:cNvSpPr/>
+          <p:nvPr/>
+        </p:nvSpPr>
+        <p:spPr>
+          <a:xfrm>
+            <a:off x="9637776" y="1911095"/>
+            <a:ext cx="1042415" cy="1005840"/>
+          </a:xfrm>
+          <a:prstGeom prst="diamond">
+            <a:avLst/>
+          </a:prstGeom>
+          <a:solidFill>
+            <a:srgbClr val="FDF0D8"/>
+          </a:solidFill>
+          <a:ln w="25400">
+            <a:solidFill>
+              <a:srgbClr val="E68A00"/>
+            </a:solidFill>
+          </a:ln>
+        </p:spPr>
+        <p:style>
+          <a:lnRef idx="1">
+            <a:schemeClr val="accent1"/>
+          </a:lnRef>
+          <a:fillRef idx="3">
+            <a:schemeClr val="accent1"/>
+          </a:fillRef>
+          <a:effectRef idx="2">
+            <a:schemeClr val="accent1"/>
+          </a:effectRef>
+          <a:fontRef idx="minor">
+            <a:schemeClr val="lt1"/>
+          </a:fontRef>
+        </p:style>
+        <p:txBody>
+          <a:bodyPr rtlCol="0" anchor="ctr" wrap="square"/>
+          <a:lstStyle/>
+          <a:p>
+            <a:pPr algn="ctr"/>
+            <a:r>
+              <a:rPr sz="850" b="1">
+                <a:solidFill>
+                  <a:srgbClr val="E68A00"/>
+                </a:solidFill>
+              </a:rPr>
+              <a:t>VAT Rate</a:t>
+            </a:r>
+          </a:p>
+          <a:p>
+            <a:pPr algn="ctr"/>
+            <a:r>
+              <a:rPr sz="850" b="1">
+                <a:solidFill>
+                  <a:srgbClr val="E68A00"/>
+                </a:solidFill>
+              </a:rPr>
+              <a:t>Confirmed</a:t>
+            </a:r>
+          </a:p>
+          <a:p>
+            <a:pPr algn="ctr"/>
+            <a:r>
+              <a:rPr sz="850" b="1">
+                <a:solidFill>
+                  <a:srgbClr val="E68A00"/>
+                </a:solidFill>
+              </a:rPr>
+              <a:t>Incorrect?</a:t>
+            </a:r>
+          </a:p>
+        </p:txBody>
+      </p:sp>
+      <p:sp>
+        <p:nvSpPr>
+          <p:cNvPr id="22" name="Rectangle 21"/>
+          <p:cNvSpPr/>
+          <p:nvPr/>
+        </p:nvSpPr>
+        <p:spPr>
+          <a:xfrm>
+            <a:off x="10881360" y="1856232"/>
+            <a:ext cx="1207008" cy="1115568"/>
+          </a:xfrm>
+          <a:prstGeom prst="rect">
+            <a:avLst/>
+          </a:prstGeom>
+          <a:solidFill>
+            <a:srgbClr val="D0EDDD"/>
+          </a:solidFill>
+          <a:ln w="31750">
+            <a:solidFill>
+              <a:srgbClr val="169B62"/>
+            </a:solidFill>
+          </a:ln>
+        </p:spPr>
+        <p:style>
+          <a:lnRef idx="1">
+            <a:schemeClr val="accent1"/>
+          </a:lnRef>
+          <a:fillRef idx="3">
+            <a:schemeClr val="accent1"/>
+          </a:fillRef>
+          <a:effectRef idx="2">
+            <a:schemeClr val="accent1"/>
+          </a:effectRef>
+          <a:fontRef idx="minor">
+            <a:schemeClr val="lt1"/>
+          </a:fontRef>
+        </p:style>
+        <p:txBody>
+          <a:bodyPr rtlCol="0" anchor="ctr" wrap="square"/>
+          <a:lstStyle/>
+          <a:p>
+            <a:pPr algn="ctr"/>
+            <a:r>
+              <a:rPr sz="950" b="1">
+                <a:solidFill>
+                  <a:srgbClr val="169B62"/>
+                </a:solidFill>
+              </a:rPr>
+              <a:t>Ireland Revenue</a:t>
+            </a:r>
+          </a:p>
+          <a:p>
+            <a:pPr algn="ctr"/>
+            <a:r>
+              <a:rPr sz="950" b="1">
+                <a:solidFill>
+                  <a:srgbClr val="169B62"/>
+                </a:solidFill>
+              </a:rPr>
+              <a:t>Investigation</a:t>
+            </a:r>
+          </a:p>
+          <a:p>
+            <a:pPr algn="ctr"/>
+            <a:r>
+              <a:rPr sz="950" b="1">
+                <a:solidFill>
+                  <a:srgbClr val="169B62"/>
+                </a:solidFill>
+              </a:rPr>
+              <a:t>Queue</a:t>
+            </a:r>
+          </a:p>
+        </p:txBody>
+      </p:sp>
+      <p:sp>
+        <p:nvSpPr>
+          <p:cNvPr id="23" name="TextBox 22"/>
+          <p:cNvSpPr txBox="1"/>
+          <p:nvPr/>
+        </p:nvSpPr>
+        <p:spPr>
+          <a:xfrm>
+            <a:off x="10954512" y="2503261"/>
+            <a:ext cx="1060704" cy="329184"/>
+          </a:xfrm>
+          <a:prstGeom prst="rect">
+            <a:avLst/>
+          </a:prstGeom>
+          <a:noFill/>
+        </p:spPr>
+        <p:txBody>
+          <a:bodyPr wrap="square">
+            <a:spAutoFit/>
+          </a:bodyPr>
+          <a:lstStyle/>
+          <a:p>
+            <a:pPr algn="ctr"/>
+            <a:r>
+              <a:rPr sz="700" b="0" i="1">
+                <a:solidFill>
+                  <a:srgbClr val="169B62"/>
+                </a:solidFill>
+              </a:rPr>
+              <a:t>Alarm evidence +</a:t>
+            </a:r>
+          </a:p>
+          <a:p>
+            <a:pPr algn="ctr"/>
+            <a:r>
+              <a:rPr sz="700" b="0" i="1">
+                <a:solidFill>
+                  <a:srgbClr val="169B62"/>
+                </a:solidFill>
+              </a:rPr>
+              <a:t>agent reasoning</a:t>
+            </a:r>
+          </a:p>
+          <a:p>
+            <a:pPr algn="ctr"/>
+            <a:r>
+              <a:rPr sz="700" b="0" i="1">
+                <a:solidFill>
+                  <a:srgbClr val="169B62"/>
+                </a:solidFill>
+              </a:rPr>
+              <a:t>provided</a:t>
+            </a:r>
+          </a:p>
+        </p:txBody>
+      </p:sp>
+      <p:sp>
+        <p:nvSpPr>
+          <p:cNvPr id="24" name="Rectangle 23"/>
+          <p:cNvSpPr/>
+          <p:nvPr/>
+        </p:nvSpPr>
+        <p:spPr>
+          <a:xfrm>
+            <a:off x="10881360" y="1618488"/>
+            <a:ext cx="1207008" cy="201168"/>
+          </a:xfrm>
+          <a:prstGeom prst="rect">
+            <a:avLst/>
+          </a:prstGeom>
+          <a:solidFill>
+            <a:srgbClr val="169B62"/>
+          </a:solidFill>
+          <a:ln>
+            <a:solidFill>
+              <a:srgbClr val="169B62"/>
+            </a:solidFill>
+          </a:ln>
+        </p:spPr>
+        <p:style>
+          <a:lnRef idx="1">
+            <a:schemeClr val="accent1"/>
+          </a:lnRef>
+          <a:fillRef idx="3">
+            <a:schemeClr val="accent1"/>
+          </a:fillRef>
+          <a:effectRef idx="2">
+            <a:schemeClr val="accent1"/>
+          </a:effectRef>
+          <a:fontRef idx="minor">
+            <a:schemeClr val="lt1"/>
+          </a:fontRef>
+        </p:style>
+        <p:txBody>
+          <a:bodyPr rtlCol="0" anchor="ctr" wrap="square"/>
+          <a:lstStyle/>
+          <a:p>
+            <a:pPr algn="ctr"/>
+            <a:r>
+              <a:rPr sz="650" b="1">
+                <a:solidFill>
+                  <a:srgbClr val="FFFFFF"/>
+                </a:solidFill>
+              </a:rPr>
+              <a:t>Irish Revenue Authority</a:t>
+            </a:r>
+          </a:p>
+        </p:txBody>
+      </p:sp>
+      <p:sp>
+        <p:nvSpPr>
+          <p:cNvPr id="25" name="Rectangle 24"/>
+          <p:cNvSpPr/>
+          <p:nvPr/>
+        </p:nvSpPr>
+        <p:spPr>
+          <a:xfrm>
+            <a:off x="10881360" y="3008376"/>
+            <a:ext cx="1207008" cy="201168"/>
+          </a:xfrm>
+          <a:prstGeom prst="rect">
+            <a:avLst/>
+          </a:prstGeom>
+          <a:solidFill>
+            <a:srgbClr val="CC2222"/>
+          </a:solidFill>
+          <a:ln>
+            <a:solidFill>
+              <a:srgbClr val="CC2222"/>
+            </a:solidFill>
+          </a:ln>
+        </p:spPr>
+        <p:style>
+          <a:lnRef idx="1">
+            <a:schemeClr val="accent1"/>
+          </a:lnRef>
+          <a:fillRef idx="3">
+            <a:schemeClr val="accent1"/>
+          </a:fillRef>
+          <a:effectRef idx="2">
+            <a:schemeClr val="accent1"/>
+          </a:effectRef>
+          <a:fontRef idx="minor">
+            <a:schemeClr val="lt1"/>
+          </a:fontRef>
+        </p:style>
+        <p:txBody>
+          <a:bodyPr rtlCol="0" anchor="ctr" wrap="square"/>
+          <a:lstStyle/>
+          <a:p>
+            <a:pPr algn="ctr"/>
+            <a:r>
+              <a:rPr sz="650" b="1">
+                <a:solidFill>
+                  <a:srgbClr val="FFFFFF"/>
+                </a:solidFill>
+              </a:rPr>
+              <a:t>Suspicion: HIGH</a:t>
+            </a:r>
+          </a:p>
+        </p:txBody>
+      </p:sp>
+      <p:sp>
+        <p:nvSpPr>
+          <p:cNvPr id="26" name="Rectangle 25"/>
+          <p:cNvSpPr/>
+          <p:nvPr/>
+        </p:nvSpPr>
+        <p:spPr>
+          <a:xfrm>
+            <a:off x="4187952" y="4434840"/>
+            <a:ext cx="1335024" cy="822960"/>
+          </a:xfrm>
+          <a:prstGeom prst="rect">
+            <a:avLst/>
+          </a:prstGeom>
+          <a:solidFill>
+            <a:srgbClr val="E9ECEF"/>
+          </a:solidFill>
+          <a:ln w="19050">
+            <a:solidFill>
+              <a:srgbClr val="6C757D"/>
+            </a:solidFill>
+          </a:ln>
+        </p:spPr>
+        <p:style>
+          <a:lnRef idx="1">
+            <a:schemeClr val="accent1"/>
+          </a:lnRef>
+          <a:fillRef idx="3">
+            <a:schemeClr val="accent1"/>
+          </a:fillRef>
+          <a:effectRef idx="2">
+            <a:schemeClr val="accent1"/>
+          </a:effectRef>
+          <a:fontRef idx="minor">
+            <a:schemeClr val="lt1"/>
+          </a:fontRef>
+        </p:style>
+        <p:txBody>
+          <a:bodyPr rtlCol="0" anchor="ctr" wrap="square"/>
+          <a:lstStyle/>
+          <a:p>
+            <a:pPr algn="ctr"/>
+            <a:r>
+              <a:rPr sz="800" b="1">
+                <a:solidFill>
+                  <a:srgbClr val="6C757D"/>
+                </a:solidFill>
+              </a:rPr>
+              <a:t>No Further Action</a:t>
+            </a:r>
+          </a:p>
+        </p:txBody>
+      </p:sp>
+      <p:sp>
+        <p:nvSpPr>
+          <p:cNvPr id="27" name="TextBox 26"/>
+          <p:cNvSpPr txBox="1"/>
+          <p:nvPr/>
+        </p:nvSpPr>
+        <p:spPr>
+          <a:xfrm>
+            <a:off x="4261104" y="4895697"/>
+            <a:ext cx="1188720" cy="274320"/>
+          </a:xfrm>
+          <a:prstGeom prst="rect">
+            <a:avLst/>
+          </a:prstGeom>
+          <a:noFill/>
+        </p:spPr>
+        <p:txBody>
+          <a:bodyPr wrap="square">
+            <a:spAutoFit/>
+          </a:bodyPr>
+          <a:lstStyle/>
+          <a:p>
+            <a:pPr algn="ctr"/>
+            <a:r>
+              <a:rPr sz="700" b="0" i="1">
+                <a:solidFill>
+                  <a:srgbClr val="6C757D"/>
+                </a:solidFill>
+              </a:rPr>
+              <a:t>Transaction within</a:t>
+            </a:r>
+          </a:p>
+          <a:p>
+            <a:pPr algn="ctr"/>
+            <a:r>
+              <a:rPr sz="700" b="0" i="1">
+                <a:solidFill>
+                  <a:srgbClr val="6C757D"/>
+                </a:solidFill>
+              </a:rPr>
+              <a:t>normal VAT parameters</a:t>
+            </a:r>
+          </a:p>
+        </p:txBody>
+      </p:sp>
+      <p:sp>
+        <p:nvSpPr>
+          <p:cNvPr id="28" name="Rectangle 27"/>
+          <p:cNvSpPr/>
+          <p:nvPr/>
+        </p:nvSpPr>
+        <p:spPr>
+          <a:xfrm>
+            <a:off x="6839711" y="4434840"/>
+            <a:ext cx="1335024" cy="822960"/>
+          </a:xfrm>
+          <a:prstGeom prst="rect">
+            <a:avLst/>
+          </a:prstGeom>
+          <a:solidFill>
+            <a:srgbClr val="E9ECEF"/>
+          </a:solidFill>
+          <a:ln w="19050">
+            <a:solidFill>
+              <a:srgbClr val="6C757D"/>
+            </a:solidFill>
+          </a:ln>
+        </p:spPr>
+        <p:style>
+          <a:lnRef idx="1">
+            <a:schemeClr val="accent1"/>
+          </a:lnRef>
+          <a:fillRef idx="3">
+            <a:schemeClr val="accent1"/>
+          </a:fillRef>
+          <a:effectRef idx="2">
+            <a:schemeClr val="accent1"/>
+          </a:effectRef>
+          <a:fontRef idx="minor">
+            <a:schemeClr val="lt1"/>
+          </a:fontRef>
+        </p:style>
+        <p:txBody>
+          <a:bodyPr rtlCol="0" anchor="ctr" wrap="square"/>
+          <a:lstStyle/>
+          <a:p>
+            <a:pPr algn="ctr"/>
+            <a:r>
+              <a:rPr sz="800" b="1">
+                <a:solidFill>
+                  <a:srgbClr val="6C757D"/>
+                </a:solidFill>
+              </a:rPr>
+              <a:t>Under Monitoring</a:t>
+            </a:r>
+          </a:p>
+        </p:txBody>
+      </p:sp>
+      <p:sp>
+        <p:nvSpPr>
+          <p:cNvPr id="29" name="TextBox 28"/>
+          <p:cNvSpPr txBox="1"/>
+          <p:nvPr/>
+        </p:nvSpPr>
+        <p:spPr>
+          <a:xfrm>
+            <a:off x="6912863" y="4895697"/>
+            <a:ext cx="1188720" cy="274320"/>
+          </a:xfrm>
+          <a:prstGeom prst="rect">
+            <a:avLst/>
+          </a:prstGeom>
+          <a:noFill/>
+        </p:spPr>
+        <p:txBody>
+          <a:bodyPr wrap="square">
+            <a:spAutoFit/>
+          </a:bodyPr>
+          <a:lstStyle/>
+          <a:p>
+            <a:pPr algn="ctr"/>
+            <a:r>
+              <a:rPr sz="700" b="0" i="1">
+                <a:solidFill>
+                  <a:srgbClr val="6C757D"/>
+                </a:solidFill>
+              </a:rPr>
+              <a:t>Alert recorded;</a:t>
+            </a:r>
+          </a:p>
+          <a:p>
+            <a:pPr algn="ctr"/>
+            <a:r>
+              <a:rPr sz="700" b="0" i="1">
+                <a:solidFill>
+                  <a:srgbClr val="6C757D"/>
+                </a:solidFill>
+              </a:rPr>
+              <a:t>no member-state referral</a:t>
+            </a:r>
+          </a:p>
+        </p:txBody>
+      </p:sp>
+      <p:sp>
+        <p:nvSpPr>
+          <p:cNvPr id="30" name="Rectangle 29"/>
+          <p:cNvSpPr/>
+          <p:nvPr/>
+        </p:nvSpPr>
+        <p:spPr>
+          <a:xfrm>
+            <a:off x="9491472" y="4434840"/>
+            <a:ext cx="1335024" cy="822960"/>
+          </a:xfrm>
+          <a:prstGeom prst="rect">
+            <a:avLst/>
+          </a:prstGeom>
+          <a:solidFill>
+            <a:srgbClr val="E9ECEF"/>
+          </a:solidFill>
+          <a:ln w="19050">
+            <a:solidFill>
+              <a:srgbClr val="6C757D"/>
+            </a:solidFill>
+          </a:ln>
+        </p:spPr>
+        <p:style>
+          <a:lnRef idx="1">
+            <a:schemeClr val="accent1"/>
+          </a:lnRef>
+          <a:fillRef idx="3">
+            <a:schemeClr val="accent1"/>
+          </a:fillRef>
+          <a:effectRef idx="2">
+            <a:schemeClr val="accent1"/>
+          </a:effectRef>
+          <a:fontRef idx="minor">
+            <a:schemeClr val="lt1"/>
+          </a:fontRef>
+        </p:style>
+        <p:txBody>
+          <a:bodyPr rtlCol="0" anchor="ctr" wrap="square"/>
+          <a:lstStyle/>
+          <a:p>
+            <a:pPr algn="ctr"/>
+            <a:r>
+              <a:rPr sz="800" b="1">
+                <a:solidFill>
+                  <a:srgbClr val="6C757D"/>
+                </a:solidFill>
+              </a:rPr>
+              <a:t>Suspicion Cleared</a:t>
+            </a:r>
+          </a:p>
+        </p:txBody>
+      </p:sp>
+      <p:sp>
+        <p:nvSpPr>
+          <p:cNvPr id="31" name="TextBox 30"/>
+          <p:cNvSpPr txBox="1"/>
+          <p:nvPr/>
+        </p:nvSpPr>
+        <p:spPr>
+          <a:xfrm>
+            <a:off x="9564624" y="4895697"/>
+            <a:ext cx="1188720" cy="274320"/>
+          </a:xfrm>
+          <a:prstGeom prst="rect">
+            <a:avLst/>
+          </a:prstGeom>
+          <a:noFill/>
+        </p:spPr>
+        <p:txBody>
+          <a:bodyPr wrap="square">
+            <a:spAutoFit/>
+          </a:bodyPr>
+          <a:lstStyle/>
+          <a:p>
+            <a:pPr algn="ctr"/>
+            <a:r>
+              <a:rPr sz="700" b="0" i="1">
+                <a:solidFill>
+                  <a:srgbClr val="6C757D"/>
+                </a:solidFill>
+              </a:rPr>
+              <a:t>Correct or inconclusive;</a:t>
+            </a:r>
+          </a:p>
+          <a:p>
+            <a:pPr algn="ctr"/>
+            <a:r>
+              <a:rPr sz="700" b="0" i="1">
+                <a:solidFill>
+                  <a:srgbClr val="6C757D"/>
+                </a:solidFill>
+              </a:rPr>
+              <a:t>no further investigation</a:t>
+            </a:r>
+          </a:p>
+        </p:txBody>
+      </p:sp>
+      <p:cxnSp>
+        <p:nvCxnSpPr>
+          <p:cNvPr id="32" name="Connector 31"/>
+          <p:cNvCxnSpPr/>
+          <p:nvPr/>
+        </p:nvCxnSpPr>
+        <p:spPr>
+          <a:xfrm>
+            <a:off x="1316736" y="2414016"/>
+            <a:ext cx="201168" cy="0"/>
+          </a:xfrm>
+          <a:prstGeom prst="line">
+            <a:avLst/>
+          </a:prstGeom>
+          <a:ln w="25400">
+            <a:solidFill>
+              <a:srgbClr val="003399"/>
+            </a:solidFill>
+            <a:tailEnd type="triangle" w="med" len="med"/>
+          </a:ln>
+        </p:spPr>
+        <p:style>
+          <a:lnRef idx="2">
+            <a:schemeClr val="accent1"/>
+          </a:lnRef>
+          <a:fillRef idx="0">
+            <a:schemeClr val="accent1"/>
+          </a:fillRef>
+          <a:effectRef idx="1">
+            <a:schemeClr val="accent1"/>
+          </a:effectRef>
+          <a:fontRef idx="minor">
+            <a:schemeClr val="tx1"/>
+          </a:fontRef>
+        </p:style>
+      </p:cxnSp>
+      <p:cxnSp>
+        <p:nvCxnSpPr>
+          <p:cNvPr id="33" name="Connector 32"/>
+          <p:cNvCxnSpPr/>
+          <p:nvPr/>
+        </p:nvCxnSpPr>
+        <p:spPr>
+          <a:xfrm>
+            <a:off x="2724912" y="2414016"/>
+            <a:ext cx="201168" cy="0"/>
+          </a:xfrm>
+          <a:prstGeom prst="line">
+            <a:avLst/>
+          </a:prstGeom>
+          <a:ln w="25400">
+            <a:solidFill>
+              <a:srgbClr val="003399"/>
+            </a:solidFill>
+            <a:tailEnd type="triangle" w="med" len="med"/>
+          </a:ln>
+        </p:spPr>
+        <p:style>
+          <a:lnRef idx="2">
+            <a:schemeClr val="accent1"/>
+          </a:lnRef>
+          <a:fillRef idx="0">
+            <a:schemeClr val="accent1"/>
+          </a:fillRef>
+          <a:effectRef idx="1">
+            <a:schemeClr val="accent1"/>
+          </a:effectRef>
+          <a:fontRef idx="minor">
+            <a:schemeClr val="tx1"/>
+          </a:fontRef>
+        </p:style>
+      </p:cxnSp>
+      <p:cxnSp>
+        <p:nvCxnSpPr>
+          <p:cNvPr id="34" name="Connector 33"/>
+          <p:cNvCxnSpPr/>
+          <p:nvPr/>
+        </p:nvCxnSpPr>
+        <p:spPr>
+          <a:xfrm>
+            <a:off x="4133088" y="2414016"/>
+            <a:ext cx="201168" cy="0"/>
+          </a:xfrm>
+          <a:prstGeom prst="line">
+            <a:avLst/>
+          </a:prstGeom>
+          <a:ln w="25400">
+            <a:solidFill>
+              <a:srgbClr val="003399"/>
+            </a:solidFill>
+            <a:tailEnd type="triangle" w="med" len="med"/>
+          </a:ln>
+        </p:spPr>
+        <p:style>
+          <a:lnRef idx="2">
+            <a:schemeClr val="accent1"/>
+          </a:lnRef>
+          <a:fillRef idx="0">
+            <a:schemeClr val="accent1"/>
+          </a:fillRef>
+          <a:effectRef idx="1">
+            <a:schemeClr val="accent1"/>
+          </a:effectRef>
+          <a:fontRef idx="minor">
+            <a:schemeClr val="tx1"/>
+          </a:fontRef>
+        </p:style>
+      </p:cxnSp>
+      <p:cxnSp>
+        <p:nvCxnSpPr>
+          <p:cNvPr id="35" name="Connector 34"/>
+          <p:cNvCxnSpPr/>
+          <p:nvPr/>
+        </p:nvCxnSpPr>
+        <p:spPr>
+          <a:xfrm>
+            <a:off x="5376672" y="2414016"/>
+            <a:ext cx="201168" cy="0"/>
+          </a:xfrm>
+          <a:prstGeom prst="line">
+            <a:avLst/>
+          </a:prstGeom>
+          <a:ln w="25400">
+            <a:solidFill>
+              <a:srgbClr val="003399"/>
+            </a:solidFill>
+            <a:tailEnd type="triangle" w="med" len="med"/>
+          </a:ln>
+        </p:spPr>
+        <p:style>
+          <a:lnRef idx="2">
+            <a:schemeClr val="accent1"/>
+          </a:lnRef>
+          <a:fillRef idx="0">
+            <a:schemeClr val="accent1"/>
+          </a:fillRef>
+          <a:effectRef idx="1">
+            <a:schemeClr val="accent1"/>
+          </a:effectRef>
+          <a:fontRef idx="minor">
+            <a:schemeClr val="tx1"/>
+          </a:fontRef>
+        </p:style>
+      </p:cxnSp>
+      <p:cxnSp>
+        <p:nvCxnSpPr>
+          <p:cNvPr id="36" name="Connector 35"/>
+          <p:cNvCxnSpPr/>
+          <p:nvPr/>
+        </p:nvCxnSpPr>
+        <p:spPr>
+          <a:xfrm>
+            <a:off x="6784848" y="2414016"/>
+            <a:ext cx="201168" cy="0"/>
+          </a:xfrm>
+          <a:prstGeom prst="line">
+            <a:avLst/>
+          </a:prstGeom>
+          <a:ln w="25400">
+            <a:solidFill>
+              <a:srgbClr val="003399"/>
+            </a:solidFill>
+            <a:tailEnd type="triangle" w="med" len="med"/>
+          </a:ln>
+        </p:spPr>
+        <p:style>
+          <a:lnRef idx="2">
+            <a:schemeClr val="accent1"/>
+          </a:lnRef>
+          <a:fillRef idx="0">
+            <a:schemeClr val="accent1"/>
+          </a:fillRef>
+          <a:effectRef idx="1">
+            <a:schemeClr val="accent1"/>
+          </a:effectRef>
+          <a:fontRef idx="minor">
+            <a:schemeClr val="tx1"/>
+          </a:fontRef>
+        </p:style>
+      </p:cxnSp>
+      <p:cxnSp>
+        <p:nvCxnSpPr>
+          <p:cNvPr id="37" name="Connector 36"/>
+          <p:cNvCxnSpPr/>
+          <p:nvPr/>
+        </p:nvCxnSpPr>
+        <p:spPr>
+          <a:xfrm>
+            <a:off x="8028431" y="2414016"/>
+            <a:ext cx="201169" cy="0"/>
+          </a:xfrm>
+          <a:prstGeom prst="line">
+            <a:avLst/>
+          </a:prstGeom>
+          <a:ln w="25400">
+            <a:solidFill>
+              <a:srgbClr val="003399"/>
+            </a:solidFill>
+            <a:tailEnd type="triangle" w="med" len="med"/>
+          </a:ln>
+        </p:spPr>
+        <p:style>
+          <a:lnRef idx="2">
+            <a:schemeClr val="accent1"/>
+          </a:lnRef>
+          <a:fillRef idx="0">
+            <a:schemeClr val="accent1"/>
+          </a:fillRef>
+          <a:effectRef idx="1">
+            <a:schemeClr val="accent1"/>
+          </a:effectRef>
+          <a:fontRef idx="minor">
+            <a:schemeClr val="tx1"/>
+          </a:fontRef>
+        </p:style>
+      </p:cxnSp>
+      <p:cxnSp>
+        <p:nvCxnSpPr>
+          <p:cNvPr id="38" name="Connector 37"/>
+          <p:cNvCxnSpPr/>
+          <p:nvPr/>
+        </p:nvCxnSpPr>
+        <p:spPr>
+          <a:xfrm>
+            <a:off x="9436608" y="2414016"/>
+            <a:ext cx="201168" cy="0"/>
+          </a:xfrm>
+          <a:prstGeom prst="line">
+            <a:avLst/>
+          </a:prstGeom>
+          <a:ln w="25400">
+            <a:solidFill>
+              <a:srgbClr val="003399"/>
+            </a:solidFill>
+            <a:tailEnd type="triangle" w="med" len="med"/>
+          </a:ln>
+        </p:spPr>
+        <p:style>
+          <a:lnRef idx="2">
+            <a:schemeClr val="accent1"/>
+          </a:lnRef>
+          <a:fillRef idx="0">
+            <a:schemeClr val="accent1"/>
+          </a:fillRef>
+          <a:effectRef idx="1">
+            <a:schemeClr val="accent1"/>
+          </a:effectRef>
+          <a:fontRef idx="minor">
+            <a:schemeClr val="tx1"/>
+          </a:fontRef>
+        </p:style>
+      </p:cxnSp>
+      <p:cxnSp>
+        <p:nvCxnSpPr>
+          <p:cNvPr id="39" name="Connector 38"/>
+          <p:cNvCxnSpPr/>
+          <p:nvPr/>
+        </p:nvCxnSpPr>
+        <p:spPr>
+          <a:xfrm>
+            <a:off x="10680192" y="2414016"/>
+            <a:ext cx="201168" cy="0"/>
+          </a:xfrm>
+          <a:prstGeom prst="line">
+            <a:avLst/>
+          </a:prstGeom>
+          <a:ln w="25400">
+            <a:solidFill>
+              <a:srgbClr val="003399"/>
+            </a:solidFill>
+            <a:tailEnd type="triangle" w="med" len="med"/>
+          </a:ln>
+        </p:spPr>
+        <p:style>
+          <a:lnRef idx="2">
+            <a:schemeClr val="accent1"/>
+          </a:lnRef>
+          <a:fillRef idx="0">
+            <a:schemeClr val="accent1"/>
+          </a:fillRef>
+          <a:effectRef idx="1">
+            <a:schemeClr val="accent1"/>
+          </a:effectRef>
+          <a:fontRef idx="minor">
+            <a:schemeClr val="tx1"/>
+          </a:fontRef>
+        </p:style>
+      </p:cxnSp>
+      <p:sp>
+        <p:nvSpPr>
+          <p:cNvPr id="40" name="TextBox 39"/>
+          <p:cNvSpPr txBox="1"/>
+          <p:nvPr/>
+        </p:nvSpPr>
+        <p:spPr>
+          <a:xfrm>
+            <a:off x="5385816" y="2212848"/>
+            <a:ext cx="182880" cy="182880"/>
+          </a:xfrm>
+          <a:prstGeom prst="rect">
+            <a:avLst/>
+          </a:prstGeom>
+          <a:noFill/>
+        </p:spPr>
+        <p:txBody>
+          <a:bodyPr wrap="square">
+            <a:spAutoFit/>
+          </a:bodyPr>
+          <a:lstStyle/>
+          <a:p>
+            <a:pPr algn="ctr"/>
+            <a:r>
+              <a:rPr sz="750" b="1" i="0">
+                <a:solidFill>
+                  <a:srgbClr val="169B62"/>
+                </a:solidFill>
+              </a:rPr>
+              <a:t>YES</a:t>
+            </a:r>
+          </a:p>
+        </p:txBody>
+      </p:sp>
+      <p:sp>
+        <p:nvSpPr>
+          <p:cNvPr id="41" name="TextBox 40"/>
+          <p:cNvSpPr txBox="1"/>
+          <p:nvPr/>
+        </p:nvSpPr>
+        <p:spPr>
+          <a:xfrm>
+            <a:off x="8037575" y="2212848"/>
+            <a:ext cx="182880" cy="182880"/>
+          </a:xfrm>
+          <a:prstGeom prst="rect">
+            <a:avLst/>
+          </a:prstGeom>
+          <a:noFill/>
+        </p:spPr>
+        <p:txBody>
+          <a:bodyPr wrap="square">
+            <a:spAutoFit/>
+          </a:bodyPr>
+          <a:lstStyle/>
+          <a:p>
+            <a:pPr algn="ctr"/>
+            <a:r>
+              <a:rPr sz="750" b="1" i="0">
+                <a:solidFill>
+                  <a:srgbClr val="169B62"/>
+                </a:solidFill>
+              </a:rPr>
+              <a:t>YES</a:t>
+            </a:r>
+          </a:p>
+        </p:txBody>
+      </p:sp>
+      <p:sp>
+        <p:nvSpPr>
+          <p:cNvPr id="42" name="TextBox 41"/>
+          <p:cNvSpPr txBox="1"/>
+          <p:nvPr/>
+        </p:nvSpPr>
+        <p:spPr>
+          <a:xfrm>
+            <a:off x="10689336" y="2212848"/>
+            <a:ext cx="182880" cy="182880"/>
+          </a:xfrm>
+          <a:prstGeom prst="rect">
+            <a:avLst/>
+          </a:prstGeom>
+          <a:noFill/>
+        </p:spPr>
+        <p:txBody>
+          <a:bodyPr wrap="square">
+            <a:spAutoFit/>
+          </a:bodyPr>
+          <a:lstStyle/>
+          <a:p>
+            <a:pPr algn="ctr"/>
+            <a:r>
+              <a:rPr sz="750" b="1" i="0">
+                <a:solidFill>
+                  <a:srgbClr val="169B62"/>
+                </a:solidFill>
+              </a:rPr>
+              <a:t>YES</a:t>
+            </a:r>
+          </a:p>
+        </p:txBody>
+      </p:sp>
+      <p:cxnSp>
+        <p:nvCxnSpPr>
+          <p:cNvPr id="43" name="Connector 42"/>
+          <p:cNvCxnSpPr/>
+          <p:nvPr/>
+        </p:nvCxnSpPr>
+        <p:spPr>
+          <a:xfrm>
+            <a:off x="4855464" y="2916936"/>
+            <a:ext cx="0" cy="1517904"/>
+          </a:xfrm>
+          <a:prstGeom prst="line">
+            <a:avLst/>
+          </a:prstGeom>
+          <a:ln w="22860">
+            <a:solidFill>
+              <a:srgbClr val="CC2222"/>
+            </a:solidFill>
+            <a:prstDash val="dash"/>
+            <a:tailEnd type="triangle" w="med" len="med"/>
+          </a:ln>
+        </p:spPr>
+        <p:style>
+          <a:lnRef idx="2">
+            <a:schemeClr val="accent1"/>
+          </a:lnRef>
+          <a:fillRef idx="0">
+            <a:schemeClr val="accent1"/>
+          </a:fillRef>
+          <a:effectRef idx="1">
+            <a:schemeClr val="accent1"/>
+          </a:effectRef>
+          <a:fontRef idx="minor">
+            <a:schemeClr val="tx1"/>
+          </a:fontRef>
+        </p:style>
+      </p:cxnSp>
+      <p:sp>
+        <p:nvSpPr>
+          <p:cNvPr id="44" name="TextBox 43"/>
+          <p:cNvSpPr txBox="1"/>
+          <p:nvPr/>
+        </p:nvSpPr>
+        <p:spPr>
+          <a:xfrm>
+            <a:off x="4892040" y="2971800"/>
+            <a:ext cx="219456" cy="164592"/>
+          </a:xfrm>
+          <a:prstGeom prst="rect">
+            <a:avLst/>
+          </a:prstGeom>
+          <a:noFill/>
+        </p:spPr>
+        <p:txBody>
+          <a:bodyPr wrap="square">
+            <a:spAutoFit/>
+          </a:bodyPr>
+          <a:lstStyle/>
+          <a:p>
+            <a:pPr algn="l"/>
+            <a:r>
+              <a:rPr sz="750" b="1" i="0">
+                <a:solidFill>
+                  <a:srgbClr val="CC2222"/>
+                </a:solidFill>
+              </a:rPr>
+              <a:t>NO</a:t>
+            </a:r>
+          </a:p>
+        </p:txBody>
+      </p:sp>
+      <p:cxnSp>
+        <p:nvCxnSpPr>
+          <p:cNvPr id="45" name="Connector 44"/>
+          <p:cNvCxnSpPr/>
+          <p:nvPr/>
+        </p:nvCxnSpPr>
+        <p:spPr>
+          <a:xfrm>
+            <a:off x="7507223" y="2916936"/>
+            <a:ext cx="0" cy="1517904"/>
+          </a:xfrm>
+          <a:prstGeom prst="line">
+            <a:avLst/>
+          </a:prstGeom>
+          <a:ln w="22860">
+            <a:solidFill>
+              <a:srgbClr val="CC2222"/>
+            </a:solidFill>
+            <a:prstDash val="dash"/>
+            <a:tailEnd type="triangle" w="med" len="med"/>
+          </a:ln>
+        </p:spPr>
+        <p:style>
+          <a:lnRef idx="2">
+            <a:schemeClr val="accent1"/>
+          </a:lnRef>
+          <a:fillRef idx="0">
+            <a:schemeClr val="accent1"/>
+          </a:fillRef>
+          <a:effectRef idx="1">
+            <a:schemeClr val="accent1"/>
+          </a:effectRef>
+          <a:fontRef idx="minor">
+            <a:schemeClr val="tx1"/>
+          </a:fontRef>
+        </p:style>
+      </p:cxnSp>
+      <p:sp>
+        <p:nvSpPr>
+          <p:cNvPr id="46" name="TextBox 45"/>
+          <p:cNvSpPr txBox="1"/>
+          <p:nvPr/>
+        </p:nvSpPr>
+        <p:spPr>
+          <a:xfrm>
+            <a:off x="7543799" y="2971800"/>
+            <a:ext cx="219456" cy="164592"/>
+          </a:xfrm>
+          <a:prstGeom prst="rect">
+            <a:avLst/>
+          </a:prstGeom>
+          <a:noFill/>
+        </p:spPr>
+        <p:txBody>
+          <a:bodyPr wrap="square">
+            <a:spAutoFit/>
+          </a:bodyPr>
+          <a:lstStyle/>
+          <a:p>
+            <a:pPr algn="l"/>
+            <a:r>
+              <a:rPr sz="750" b="1" i="0">
+                <a:solidFill>
+                  <a:srgbClr val="CC2222"/>
+                </a:solidFill>
+              </a:rPr>
+              <a:t>NO</a:t>
+            </a:r>
+          </a:p>
+        </p:txBody>
+      </p:sp>
+      <p:cxnSp>
+        <p:nvCxnSpPr>
+          <p:cNvPr id="47" name="Connector 46"/>
+          <p:cNvCxnSpPr/>
+          <p:nvPr/>
+        </p:nvCxnSpPr>
+        <p:spPr>
+          <a:xfrm>
+            <a:off x="10158984" y="2916936"/>
+            <a:ext cx="0" cy="1517904"/>
+          </a:xfrm>
+          <a:prstGeom prst="line">
+            <a:avLst/>
+          </a:prstGeom>
+          <a:ln w="22860">
+            <a:solidFill>
+              <a:srgbClr val="CC2222"/>
+            </a:solidFill>
+            <a:prstDash val="dash"/>
+            <a:tailEnd type="triangle" w="med" len="med"/>
+          </a:ln>
+        </p:spPr>
+        <p:style>
+          <a:lnRef idx="2">
+            <a:schemeClr val="accent1"/>
+          </a:lnRef>
+          <a:fillRef idx="0">
+            <a:schemeClr val="accent1"/>
+          </a:fillRef>
+          <a:effectRef idx="1">
+            <a:schemeClr val="accent1"/>
+          </a:effectRef>
+          <a:fontRef idx="minor">
+            <a:schemeClr val="tx1"/>
+          </a:fontRef>
+        </p:style>
+      </p:cxnSp>
+      <p:sp>
+        <p:nvSpPr>
+          <p:cNvPr id="48" name="TextBox 47"/>
+          <p:cNvSpPr txBox="1"/>
+          <p:nvPr/>
+        </p:nvSpPr>
+        <p:spPr>
+          <a:xfrm>
+            <a:off x="10195560" y="2971800"/>
+            <a:ext cx="219456" cy="164592"/>
+          </a:xfrm>
+          <a:prstGeom prst="rect">
+            <a:avLst/>
+          </a:prstGeom>
+          <a:noFill/>
+        </p:spPr>
+        <p:txBody>
+          <a:bodyPr wrap="square">
+            <a:spAutoFit/>
+          </a:bodyPr>
+          <a:lstStyle/>
+          <a:p>
+            <a:pPr algn="l"/>
+            <a:r>
+              <a:rPr sz="750" b="1" i="0">
+                <a:solidFill>
+                  <a:srgbClr val="CC2222"/>
+                </a:solidFill>
+              </a:rPr>
+              <a:t>NO</a:t>
+            </a:r>
+          </a:p>
+        </p:txBody>
+      </p:sp>
+      <p:sp>
+        <p:nvSpPr>
+          <p:cNvPr id="49" name="Rectangle 48"/>
+          <p:cNvSpPr/>
+          <p:nvPr/>
+        </p:nvSpPr>
+        <p:spPr>
+          <a:xfrm>
+            <a:off x="91439" y="6364224"/>
+            <a:ext cx="12033504" cy="438912"/>
+          </a:xfrm>
+          <a:prstGeom prst="rect">
+            <a:avLst/>
+          </a:prstGeom>
+          <a:solidFill>
+            <a:srgbClr val="FFFFFF"/>
+          </a:solidFill>
+          <a:ln w="6350">
+            <a:solidFill>
+              <a:srgbClr val="AAAAAA"/>
+            </a:solidFill>
+          </a:ln>
+        </p:spPr>
+        <p:style>
+          <a:lnRef idx="1">
+            <a:schemeClr val="accent1"/>
+          </a:lnRef>
+          <a:fillRef idx="3">
+            <a:schemeClr val="accent1"/>
+          </a:fillRef>
+          <a:effectRef idx="2">
+            <a:schemeClr val="accent1"/>
+          </a:effectRef>
+          <a:fontRef idx="minor">
+            <a:schemeClr val="lt1"/>
+          </a:fontRef>
+        </p:style>
+        <p:txBody>
+          <a:bodyPr rtlCol="0" anchor="ctr"/>
+          <a:lstStyle/>
+          <a:p>
+            <a:pPr algn="ctr"/>
+          </a:p>
+        </p:txBody>
+      </p:sp>
+      <p:sp>
+        <p:nvSpPr>
+          <p:cNvPr id="50" name="TextBox 49"/>
+          <p:cNvSpPr txBox="1"/>
+          <p:nvPr/>
+        </p:nvSpPr>
+        <p:spPr>
+          <a:xfrm>
+            <a:off x="164592" y="6400800"/>
+            <a:ext cx="914400" cy="164592"/>
+          </a:xfrm>
+          <a:prstGeom prst="rect">
+            <a:avLst/>
+          </a:prstGeom>
+          <a:noFill/>
+        </p:spPr>
+        <p:txBody>
+          <a:bodyPr wrap="square">
+            <a:spAutoFit/>
+          </a:bodyPr>
+          <a:lstStyle/>
+          <a:p>
+            <a:pPr algn="l"/>
+            <a:r>
+              <a:rPr sz="700" b="1" i="0">
+                <a:solidFill>
+                  <a:srgbClr val="222222"/>
+                </a:solidFill>
+              </a:rPr>
+              <a:t>COLOUR CODE</a:t>
+            </a:r>
+          </a:p>
+        </p:txBody>
+      </p:sp>
+      <p:sp>
+        <p:nvSpPr>
+          <p:cNvPr id="51" name="Rectangle 50"/>
+          <p:cNvSpPr/>
+          <p:nvPr/>
+        </p:nvSpPr>
+        <p:spPr>
+          <a:xfrm>
+            <a:off x="164592" y="6620256"/>
+            <a:ext cx="164592" cy="146304"/>
+          </a:xfrm>
+          <a:prstGeom prst="rect">
+            <a:avLst/>
+          </a:prstGeom>
+          <a:solidFill>
+            <a:srgbClr val="003399"/>
+          </a:solidFill>
+          <a:ln>
+            <a:solidFill>
+              <a:srgbClr val="003399"/>
+            </a:solidFill>
+          </a:ln>
+        </p:spPr>
+        <p:style>
+          <a:lnRef idx="1">
+            <a:schemeClr val="accent1"/>
+          </a:lnRef>
+          <a:fillRef idx="3">
+            <a:schemeClr val="accent1"/>
+          </a:fillRef>
+          <a:effectRef idx="2">
+            <a:schemeClr val="accent1"/>
+          </a:effectRef>
+          <a:fontRef idx="minor">
+            <a:schemeClr val="lt1"/>
+          </a:fontRef>
+        </p:style>
+        <p:txBody>
+          <a:bodyPr rtlCol="0" anchor="ctr"/>
+          <a:lstStyle/>
+          <a:p>
+            <a:pPr algn="ctr"/>
+          </a:p>
+        </p:txBody>
+      </p:sp>
+      <p:sp>
+        <p:nvSpPr>
+          <p:cNvPr id="52" name="TextBox 51"/>
+          <p:cNvSpPr txBox="1"/>
+          <p:nvPr/>
+        </p:nvSpPr>
+        <p:spPr>
+          <a:xfrm>
+            <a:off x="365759" y="6601968"/>
+            <a:ext cx="1463040" cy="182880"/>
+          </a:xfrm>
+          <a:prstGeom prst="rect">
+            <a:avLst/>
+          </a:prstGeom>
+          <a:noFill/>
+        </p:spPr>
+        <p:txBody>
+          <a:bodyPr wrap="square">
+            <a:spAutoFit/>
+          </a:bodyPr>
+          <a:lstStyle/>
+          <a:p>
+            <a:pPr algn="l"/>
+            <a:r>
+              <a:rPr sz="650" b="0" i="0">
+                <a:solidFill>
+                  <a:srgbClr val="222222"/>
+                </a:solidFill>
+              </a:rPr>
+              <a:t>EU Custom Data Hub process</a:t>
+            </a:r>
+          </a:p>
+        </p:txBody>
+      </p:sp>
+      <p:sp>
+        <p:nvSpPr>
+          <p:cNvPr id="53" name="Rectangle 52"/>
+          <p:cNvSpPr/>
+          <p:nvPr/>
+        </p:nvSpPr>
+        <p:spPr>
+          <a:xfrm>
+            <a:off x="1920240" y="6620256"/>
+            <a:ext cx="164592" cy="146304"/>
+          </a:xfrm>
+          <a:prstGeom prst="rect">
+            <a:avLst/>
+          </a:prstGeom>
+          <a:solidFill>
+            <a:srgbClr val="CC2222"/>
+          </a:solidFill>
+          <a:ln>
+            <a:solidFill>
+              <a:srgbClr val="CC2222"/>
+            </a:solidFill>
+          </a:ln>
+        </p:spPr>
+        <p:style>
+          <a:lnRef idx="1">
+            <a:schemeClr val="accent1"/>
+          </a:lnRef>
+          <a:fillRef idx="3">
+            <a:schemeClr val="accent1"/>
+          </a:fillRef>
+          <a:effectRef idx="2">
+            <a:schemeClr val="accent1"/>
+          </a:effectRef>
+          <a:fontRef idx="minor">
+            <a:schemeClr val="lt1"/>
+          </a:fontRef>
+        </p:style>
+        <p:txBody>
+          <a:bodyPr rtlCol="0" anchor="ctr"/>
+          <a:lstStyle/>
+          <a:p>
+            <a:pPr algn="ctr"/>
+          </a:p>
+        </p:txBody>
+      </p:sp>
+      <p:sp>
+        <p:nvSpPr>
+          <p:cNvPr id="54" name="TextBox 53"/>
+          <p:cNvSpPr txBox="1"/>
+          <p:nvPr/>
+        </p:nvSpPr>
+        <p:spPr>
+          <a:xfrm>
+            <a:off x="2121408" y="6601968"/>
+            <a:ext cx="1463040" cy="182880"/>
+          </a:xfrm>
+          <a:prstGeom prst="rect">
+            <a:avLst/>
+          </a:prstGeom>
+          <a:noFill/>
+        </p:spPr>
+        <p:txBody>
+          <a:bodyPr wrap="square">
+            <a:spAutoFit/>
+          </a:bodyPr>
+          <a:lstStyle/>
+          <a:p>
+            <a:pPr algn="l"/>
+            <a:r>
+              <a:rPr sz="650" b="0" i="0">
+                <a:solidFill>
+                  <a:srgbClr val="222222"/>
+                </a:solidFill>
+              </a:rPr>
+              <a:t>VAT deviation alert</a:t>
+            </a:r>
+          </a:p>
+        </p:txBody>
+      </p:sp>
+      <p:sp>
+        <p:nvSpPr>
+          <p:cNvPr id="55" name="Rectangle 54"/>
+          <p:cNvSpPr/>
+          <p:nvPr/>
+        </p:nvSpPr>
+        <p:spPr>
+          <a:xfrm>
+            <a:off x="3675887" y="6620256"/>
+            <a:ext cx="164592" cy="146304"/>
+          </a:xfrm>
+          <a:prstGeom prst="rect">
+            <a:avLst/>
+          </a:prstGeom>
+          <a:solidFill>
+            <a:srgbClr val="E68A00"/>
+          </a:solidFill>
+          <a:ln>
+            <a:solidFill>
+              <a:srgbClr val="E68A00"/>
+            </a:solidFill>
+          </a:ln>
+        </p:spPr>
+        <p:style>
+          <a:lnRef idx="1">
+            <a:schemeClr val="accent1"/>
+          </a:lnRef>
+          <a:fillRef idx="3">
+            <a:schemeClr val="accent1"/>
+          </a:fillRef>
+          <a:effectRef idx="2">
+            <a:schemeClr val="accent1"/>
+          </a:effectRef>
+          <a:fontRef idx="minor">
+            <a:schemeClr val="lt1"/>
+          </a:fontRef>
+        </p:style>
+        <p:txBody>
+          <a:bodyPr rtlCol="0" anchor="ctr"/>
+          <a:lstStyle/>
+          <a:p>
+            <a:pPr algn="ctr"/>
+          </a:p>
+        </p:txBody>
+      </p:sp>
+      <p:sp>
+        <p:nvSpPr>
+          <p:cNvPr id="56" name="TextBox 55"/>
+          <p:cNvSpPr txBox="1"/>
+          <p:nvPr/>
+        </p:nvSpPr>
+        <p:spPr>
+          <a:xfrm>
+            <a:off x="3877055" y="6601968"/>
+            <a:ext cx="1463040" cy="182880"/>
+          </a:xfrm>
+          <a:prstGeom prst="rect">
+            <a:avLst/>
+          </a:prstGeom>
+          <a:noFill/>
+        </p:spPr>
+        <p:txBody>
+          <a:bodyPr wrap="square">
+            <a:spAutoFit/>
+          </a:bodyPr>
+          <a:lstStyle/>
+          <a:p>
+            <a:pPr algn="l"/>
+            <a:r>
+              <a:rPr sz="650" b="0" i="0">
+                <a:solidFill>
+                  <a:srgbClr val="222222"/>
+                </a:solidFill>
+              </a:rPr>
+              <a:t>Decision / routing point</a:t>
+            </a:r>
+          </a:p>
+        </p:txBody>
+      </p:sp>
+      <p:sp>
+        <p:nvSpPr>
+          <p:cNvPr id="57" name="Rectangle 56"/>
+          <p:cNvSpPr/>
+          <p:nvPr/>
+        </p:nvSpPr>
+        <p:spPr>
+          <a:xfrm>
+            <a:off x="5431536" y="6620256"/>
+            <a:ext cx="164592" cy="146304"/>
+          </a:xfrm>
+          <a:prstGeom prst="rect">
+            <a:avLst/>
+          </a:prstGeom>
+          <a:solidFill>
+            <a:srgbClr val="6A3D9A"/>
+          </a:solidFill>
+          <a:ln>
+            <a:solidFill>
+              <a:srgbClr val="6A3D9A"/>
+            </a:solidFill>
+          </a:ln>
+        </p:spPr>
+        <p:style>
+          <a:lnRef idx="1">
+            <a:schemeClr val="accent1"/>
+          </a:lnRef>
+          <a:fillRef idx="3">
+            <a:schemeClr val="accent1"/>
+          </a:fillRef>
+          <a:effectRef idx="2">
+            <a:schemeClr val="accent1"/>
+          </a:effectRef>
+          <a:fontRef idx="minor">
+            <a:schemeClr val="lt1"/>
+          </a:fontRef>
+        </p:style>
+        <p:txBody>
+          <a:bodyPr rtlCol="0" anchor="ctr"/>
+          <a:lstStyle/>
+          <a:p>
+            <a:pPr algn="ctr"/>
+          </a:p>
+        </p:txBody>
+      </p:sp>
+      <p:sp>
+        <p:nvSpPr>
+          <p:cNvPr id="58" name="TextBox 57"/>
+          <p:cNvSpPr txBox="1"/>
+          <p:nvPr/>
+        </p:nvSpPr>
+        <p:spPr>
+          <a:xfrm>
+            <a:off x="5632703" y="6601968"/>
+            <a:ext cx="1463040" cy="182880"/>
+          </a:xfrm>
+          <a:prstGeom prst="rect">
+            <a:avLst/>
+          </a:prstGeom>
+          <a:noFill/>
+        </p:spPr>
+        <p:txBody>
+          <a:bodyPr wrap="square">
+            <a:spAutoFit/>
+          </a:bodyPr>
+          <a:lstStyle/>
+          <a:p>
+            <a:pPr algn="l"/>
+            <a:r>
+              <a:rPr sz="650" b="0" i="0">
+                <a:solidFill>
+                  <a:srgbClr val="222222"/>
+                </a:solidFill>
+              </a:rPr>
+              <a:t>AI compliance agent</a:t>
+            </a:r>
+          </a:p>
+        </p:txBody>
+      </p:sp>
+      <p:sp>
+        <p:nvSpPr>
+          <p:cNvPr id="59" name="Rectangle 58"/>
+          <p:cNvSpPr/>
+          <p:nvPr/>
+        </p:nvSpPr>
+        <p:spPr>
+          <a:xfrm>
+            <a:off x="7187183" y="6620256"/>
+            <a:ext cx="164592" cy="146304"/>
+          </a:xfrm>
+          <a:prstGeom prst="rect">
+            <a:avLst/>
+          </a:prstGeom>
+          <a:solidFill>
+            <a:srgbClr val="169B62"/>
+          </a:solidFill>
+          <a:ln>
+            <a:solidFill>
+              <a:srgbClr val="169B62"/>
+            </a:solidFill>
+          </a:ln>
+        </p:spPr>
+        <p:style>
+          <a:lnRef idx="1">
+            <a:schemeClr val="accent1"/>
+          </a:lnRef>
+          <a:fillRef idx="3">
+            <a:schemeClr val="accent1"/>
+          </a:fillRef>
+          <a:effectRef idx="2">
+            <a:schemeClr val="accent1"/>
+          </a:effectRef>
+          <a:fontRef idx="minor">
+            <a:schemeClr val="lt1"/>
+          </a:fontRef>
+        </p:style>
+        <p:txBody>
+          <a:bodyPr rtlCol="0" anchor="ctr"/>
+          <a:lstStyle/>
+          <a:p>
+            <a:pPr algn="ctr"/>
+          </a:p>
+        </p:txBody>
+      </p:sp>
+      <p:sp>
+        <p:nvSpPr>
+          <p:cNvPr id="60" name="TextBox 59"/>
+          <p:cNvSpPr txBox="1"/>
+          <p:nvPr/>
+        </p:nvSpPr>
+        <p:spPr>
+          <a:xfrm>
+            <a:off x="7388351" y="6601968"/>
+            <a:ext cx="1463040" cy="182880"/>
+          </a:xfrm>
+          <a:prstGeom prst="rect">
+            <a:avLst/>
+          </a:prstGeom>
+          <a:noFill/>
+        </p:spPr>
+        <p:txBody>
+          <a:bodyPr wrap="square">
+            <a:spAutoFit/>
+          </a:bodyPr>
+          <a:lstStyle/>
+          <a:p>
+            <a:pPr algn="l"/>
+            <a:r>
+              <a:rPr sz="650" b="0" i="0">
+                <a:solidFill>
+                  <a:srgbClr val="222222"/>
+                </a:solidFill>
+              </a:rPr>
+              <a:t>Ireland Revenue investigation</a:t>
+            </a:r>
+          </a:p>
+        </p:txBody>
+      </p:sp>
+      <p:sp>
+        <p:nvSpPr>
+          <p:cNvPr id="61" name="Rectangle 60"/>
+          <p:cNvSpPr/>
+          <p:nvPr/>
+        </p:nvSpPr>
+        <p:spPr>
+          <a:xfrm>
+            <a:off x="8942832" y="6620256"/>
+            <a:ext cx="164592" cy="146304"/>
+          </a:xfrm>
+          <a:prstGeom prst="rect">
+            <a:avLst/>
+          </a:prstGeom>
+          <a:solidFill>
+            <a:srgbClr val="6C757D"/>
+          </a:solidFill>
+          <a:ln>
+            <a:solidFill>
+              <a:srgbClr val="6C757D"/>
+            </a:solidFill>
+          </a:ln>
+        </p:spPr>
+        <p:style>
+          <a:lnRef idx="1">
+            <a:schemeClr val="accent1"/>
+          </a:lnRef>
+          <a:fillRef idx="3">
+            <a:schemeClr val="accent1"/>
+          </a:fillRef>
+          <a:effectRef idx="2">
+            <a:schemeClr val="accent1"/>
+          </a:effectRef>
+          <a:fontRef idx="minor">
+            <a:schemeClr val="lt1"/>
+          </a:fontRef>
+        </p:style>
+        <p:txBody>
+          <a:bodyPr rtlCol="0" anchor="ctr"/>
+          <a:lstStyle/>
+          <a:p>
+            <a:pPr algn="ctr"/>
+          </a:p>
+        </p:txBody>
+      </p:sp>
+      <p:sp>
+        <p:nvSpPr>
+          <p:cNvPr id="62" name="TextBox 61"/>
+          <p:cNvSpPr txBox="1"/>
+          <p:nvPr/>
+        </p:nvSpPr>
+        <p:spPr>
+          <a:xfrm>
+            <a:off x="9143999" y="6601968"/>
+            <a:ext cx="1463040" cy="182880"/>
+          </a:xfrm>
+          <a:prstGeom prst="rect">
+            <a:avLst/>
+          </a:prstGeom>
+          <a:noFill/>
+        </p:spPr>
+        <p:txBody>
+          <a:bodyPr wrap="square">
+            <a:spAutoFit/>
+          </a:bodyPr>
+          <a:lstStyle/>
+          <a:p>
+            <a:pPr algn="l"/>
+            <a:r>
+              <a:rPr sz="650" b="0" i="0">
+                <a:solidFill>
+                  <a:srgbClr val="222222"/>
+                </a:solidFill>
+              </a:rPr>
+              <a:t>Terminal — no further action</a:t>
             </a:r>
           </a:p>
         </p:txBody>

</xml_diff>